<commit_message>
fix(docs): add QR code to ppt
</commit_message>
<xml_diff>
--- a/docs/SDD-Agentic-Engineering.pptx
+++ b/docs/SDD-Agentic-Engineering.pptx
@@ -4,6 +4,9 @@
   <p:sldMasterIdLst>
     <p:sldMasterId id="2147483648" r:id="rId1"/>
   </p:sldMasterIdLst>
+  <p:notesMasterIdLst>
+    <p:notesMasterId r:id="rId18"/>
+  </p:notesMasterIdLst>
   <p:sldIdLst>
     <p:sldId id="256" r:id="rId2"/>
     <p:sldId id="257" r:id="rId3"/>
@@ -22,10 +25,7 @@
     <p:sldId id="270" r:id="rId16"/>
     <p:sldId id="271" r:id="rId17"/>
   </p:sldIdLst>
-  <p:notesMasterIdLst>
-    <p:notesMasterId r:id="rId18"/>
-  </p:notesMasterIdLst>
-  <p:sldSz cx="9144000" cy="5143500"/>
+  <p:sldSz cx="9144000" cy="5143500" type="screen16x9"/>
   <p:notesSz cx="5143500" cy="9144000"/>
   <p:defaultTextStyle>
     <a:lvl1pPr marL="0" algn="l" defTabSz="914400" rtl="0" eaLnBrk="1" latinLnBrk="0" hangingPunct="1">
@@ -122,14 +122,14 @@
   <p:extLst>
     <p:ext uri="{521415D9-36F7-43E2-AB2F-B90AF26B5E84}">
       <p14:sectionLst xmlns:p14="http://schemas.microsoft.com/office/powerpoint/2010/main">
-        <p14:section name="Why" id="{51ff2e03-2fcd-5851-b8fe-ff816c9638da}">
+        <p14:section name="Why" id="{51FF2E03-2FCD-5851-B8FE-FF816C9638DA}">
           <p14:sldIdLst>
             <p14:sldId id="256"/>
             <p14:sldId id="257"/>
             <p14:sldId id="258"/>
           </p14:sldIdLst>
         </p14:section>
-        <p14:section name="SDD" id="{640eae1d-35a4-c4f1-86e9-cc868cf2a08c}">
+        <p14:section name="SDD" id="{640EAE1D-35A4-C4F1-86E9-CC868CF2A08C}">
           <p14:sldIdLst>
             <p14:sldId id="259"/>
             <p14:sldId id="260"/>
@@ -137,7 +137,7 @@
             <p14:sldId id="262"/>
           </p14:sldIdLst>
         </p14:section>
-        <p14:section name="Agentic" id="{218e29cc-c965-2e03-464a-42b5defb4016}">
+        <p14:section name="Agentic" id="{218E29CC-C965-2E03-464A-42B5DEFB4016}">
           <p14:sldIdLst>
             <p14:sldId id="263"/>
             <p14:sldId id="264"/>
@@ -147,7 +147,7 @@
             <p14:sldId id="268"/>
           </p14:sldIdLst>
         </p14:section>
-        <p14:section name="Practice" id="{598d17a0-7615-1199-b448-f092264431df}">
+        <p14:section name="Practice" id="{598D17A0-7615-1199-B448-F092264431DF}">
           <p14:sldIdLst>
             <p14:sldId id="269"/>
             <p14:sldId id="270"/>
@@ -185,234 +185,10 @@
           <a:chExt cx="0" cy="0"/>
         </a:xfrm>
       </p:grpSpPr>
-      <p:sp>
-        <p:nvSpPr>
-          <p:cNvPr id="2" name="Header Placeholder 1"/>
-          <p:cNvSpPr>
-            <a:spLocks noGrp="1"/>
-          </p:cNvSpPr>
-          <p:nvPr>
-            <p:ph type="hdr" sz="quarter"/>
-          </p:nvPr>
-        </p:nvSpPr>
-        <p:spPr>
-          <a:xfrm>
-            <a:off x="0" y="0"/>
-            <a:ext cx="2971800" cy="458788"/>
-          </a:xfrm>
-          <a:prstGeom prst="rect">
-            <a:avLst/>
-          </a:prstGeom>
-        </p:spPr>
-        <p:txBody>
-          <a:bodyPr vert="horz" lIns="91440" tIns="45720" rIns="91440" bIns="45720" rtlCol="0"/>
-          <a:lstStyle>
-            <a:lvl1pPr algn="l">
-              <a:defRPr sz="1200"/>
-            </a:lvl1pPr>
-          </a:lstStyle>
-          <a:p>
-            <a:endParaRPr lang="en-US"/>
-          </a:p>
-        </p:txBody>
-      </p:sp>
-      <p:sp>
-        <p:nvSpPr>
-          <p:cNvPr id="3" name="Date Placeholder 2"/>
-          <p:cNvSpPr>
-            <a:spLocks noGrp="1"/>
-          </p:cNvSpPr>
-          <p:nvPr>
-            <p:ph type="dt" idx="1"/>
-          </p:nvPr>
-        </p:nvSpPr>
-        <p:spPr>
-          <a:xfrm>
-            <a:off x="3884613" y="0"/>
-            <a:ext cx="2971800" cy="458788"/>
-          </a:xfrm>
-          <a:prstGeom prst="rect">
-            <a:avLst/>
-          </a:prstGeom>
-        </p:spPr>
-        <p:txBody>
-          <a:bodyPr vert="horz" lIns="91440" tIns="45720" rIns="91440" bIns="45720" rtlCol="0"/>
-          <a:lstStyle>
-            <a:lvl1pPr algn="r">
-              <a:defRPr sz="1200"/>
-            </a:lvl1pPr>
-          </a:lstStyle>
-          <a:p>
-            <a:fld id="{5282F153-3F37-0F45-9E97-73ACFA13230C}" type="datetimeFigureOut">
-              <a:rPr lang="en-US"/>
-              <a:t>7/23/19</a:t>
-            </a:fld>
-            <a:endParaRPr lang="en-US"/>
-          </a:p>
-        </p:txBody>
-      </p:sp>
-      <p:sp>
-        <p:nvSpPr>
-          <p:cNvPr id="4" name="Slide Image Placeholder 3"/>
-          <p:cNvSpPr>
-            <a:spLocks noGrp="1" noRot="1" noChangeAspect="1"/>
-          </p:cNvSpPr>
-          <p:nvPr>
-            <p:ph type="sldImg" idx="2"/>
-          </p:nvPr>
-        </p:nvSpPr>
-        <p:spPr>
-          <a:xfrm>
-            <a:off x="685800" y="1143000"/>
-            <a:ext cx="5486400" cy="3086100"/>
-          </a:xfrm>
-          <a:prstGeom prst="rect">
-            <a:avLst/>
-          </a:prstGeom>
-          <a:noFill/>
-          <a:ln w="12700">
-            <a:solidFill>
-              <a:prstClr val="black"/>
-            </a:solidFill>
-          </a:ln>
-        </p:spPr>
-        <p:txBody>
-          <a:bodyPr vert="horz" lIns="91440" tIns="45720" rIns="91440" bIns="45720" rtlCol="0" anchor="ctr"/>
-          <a:lstStyle/>
-          <a:p>
-            <a:endParaRPr lang="en-US"/>
-          </a:p>
-        </p:txBody>
-      </p:sp>
-      <p:sp>
-        <p:nvSpPr>
-          <p:cNvPr id="5" name="Notes Placeholder 4"/>
-          <p:cNvSpPr>
-            <a:spLocks noGrp="1"/>
-          </p:cNvSpPr>
-          <p:nvPr>
-            <p:ph type="body" sz="quarter" idx="3"/>
-          </p:nvPr>
-        </p:nvSpPr>
-        <p:spPr>
-          <a:xfrm>
-            <a:off x="685800" y="4400550"/>
-            <a:ext cx="5486400" cy="3600450"/>
-          </a:xfrm>
-          <a:prstGeom prst="rect">
-            <a:avLst/>
-          </a:prstGeom>
-        </p:spPr>
-        <p:txBody>
-          <a:bodyPr vert="horz" lIns="91440" tIns="45720" rIns="91440" bIns="45720" rtlCol="0"/>
-          <a:lstStyle/>
-          <a:p>
-            <a:pPr lvl="0"/>
-            <a:r>
-              <a:rPr lang="en-US"/>
-              <a:t>Click to edit Master text styles</a:t>
-            </a:r>
-          </a:p>
-          <a:p>
-            <a:pPr lvl="1"/>
-            <a:r>
-              <a:rPr lang="en-US"/>
-              <a:t>Second level</a:t>
-            </a:r>
-          </a:p>
-          <a:p>
-            <a:pPr lvl="2"/>
-            <a:r>
-              <a:rPr lang="en-US"/>
-              <a:t>Third level</a:t>
-            </a:r>
-          </a:p>
-          <a:p>
-            <a:pPr lvl="3"/>
-            <a:r>
-              <a:rPr lang="en-US"/>
-              <a:t>Fourth level</a:t>
-            </a:r>
-          </a:p>
-          <a:p>
-            <a:pPr lvl="4"/>
-            <a:r>
-              <a:rPr lang="en-US"/>
-              <a:t>Fifth level</a:t>
-            </a:r>
-          </a:p>
-        </p:txBody>
-      </p:sp>
-      <p:sp>
-        <p:nvSpPr>
-          <p:cNvPr id="6" name="Footer Placeholder 5"/>
-          <p:cNvSpPr>
-            <a:spLocks noGrp="1"/>
-          </p:cNvSpPr>
-          <p:nvPr>
-            <p:ph type="ftr" sz="quarter" idx="4"/>
-          </p:nvPr>
-        </p:nvSpPr>
-        <p:spPr>
-          <a:xfrm>
-            <a:off x="0" y="8685213"/>
-            <a:ext cx="2971800" cy="458787"/>
-          </a:xfrm>
-          <a:prstGeom prst="rect">
-            <a:avLst/>
-          </a:prstGeom>
-        </p:spPr>
-        <p:txBody>
-          <a:bodyPr vert="horz" lIns="91440" tIns="45720" rIns="91440" bIns="45720" rtlCol="0" anchor="b"/>
-          <a:lstStyle>
-            <a:lvl1pPr algn="l">
-              <a:defRPr sz="1200"/>
-            </a:lvl1pPr>
-          </a:lstStyle>
-          <a:p>
-            <a:endParaRPr lang="en-US"/>
-          </a:p>
-        </p:txBody>
-      </p:sp>
-      <p:sp>
-        <p:nvSpPr>
-          <p:cNvPr id="7" name="Slide Number Placeholder 6"/>
-          <p:cNvSpPr>
-            <a:spLocks noGrp="1"/>
-          </p:cNvSpPr>
-          <p:nvPr>
-            <p:ph type="sldNum" sz="quarter" idx="5"/>
-          </p:nvPr>
-        </p:nvSpPr>
-        <p:spPr>
-          <a:xfrm>
-            <a:off x="3884613" y="8685213"/>
-            <a:ext cx="2971800" cy="458787"/>
-          </a:xfrm>
-          <a:prstGeom prst="rect">
-            <a:avLst/>
-          </a:prstGeom>
-        </p:spPr>
-        <p:txBody>
-          <a:bodyPr vert="horz" lIns="91440" tIns="45720" rIns="91440" bIns="45720" rtlCol="0" anchor="b"/>
-          <a:lstStyle>
-            <a:lvl1pPr algn="r">
-              <a:defRPr sz="1200"/>
-            </a:lvl1pPr>
-          </a:lstStyle>
-          <a:p>
-            <a:fld id="{CE5E9CC1-C706-0F49-92D6-E571CC5EEA8F}" type="slidenum">
-              <a:rPr lang="en-US"/>
-              <a:t>‹#›</a:t>
-            </a:fld>
-            <a:endParaRPr lang="en-US"/>
-          </a:p>
-        </p:txBody>
-      </p:sp>
     </p:spTree>
     <p:extLst>
       <p:ext uri="{BB962C8B-B14F-4D97-AF65-F5344CB8AC3E}">
-        <p14:creationId xmlns:p14="http://schemas.microsoft.com/office/powerpoint/2010/main" val="1024086991"/>
+        <p14:creationId xmlns:p14="http://schemas.microsoft.com/office/powerpoint/2010/main" val="1530174908"/>
       </p:ext>
     </p:extLst>
   </p:cSld>
@@ -560,7 +336,6 @@
               <a:rPr lang="en-US" dirty="0"/>
               <a:t>Welcome. 15 minutes of ideas, 15 minutes of code. Everything you'll see is in a public repo with one git tag per step, so you can replay it at home with Gemini CLI.</a:t>
             </a:r>
-            <a:endParaRPr lang="en-US" dirty="0"/>
           </a:p>
         </p:txBody>
       </p:sp>
@@ -648,7 +423,6 @@
               <a:rPr lang="en-US" dirty="0"/>
               <a:t>Agentic engineering is not 'let the AI do it'. You're the architect and reviewer; the agent is a fast, tireless implementer. The middle column are the gates: you review each artifact before the next step runs.</a:t>
             </a:r>
-            <a:endParaRPr lang="en-US" dirty="0"/>
           </a:p>
         </p:txBody>
       </p:sp>
@@ -736,7 +510,6 @@
               <a:rPr lang="en-US" dirty="0"/>
               <a:t>The model only knows what's in its context window. Chat history is fragile; files are durable and reviewable. Layer it: standing rules on top, then the spec, the plan, the current task, and finally the code and tests as ground truth. Keep each layer small and relevant — dumping the whole repo in makes results worse, not better.</a:t>
             </a:r>
-            <a:endParaRPr lang="en-US" dirty="0"/>
           </a:p>
         </p:txBody>
       </p:sp>
@@ -824,7 +597,6 @@
               <a:rPr lang="en-US" dirty="0"/>
               <a:t>Agents are confident, not correct. So you build the guardrails an SRE would: tests as the oracle, small diffs you can actually review, explicit human approval on the artifacts, and a sandbox with least privilege plus CI so nothing red merges. The motto flips: verify first, then trust.</a:t>
             </a:r>
-            <a:endParaRPr lang="en-US" dirty="0"/>
           </a:p>
         </p:txBody>
       </p:sp>
@@ -912,7 +684,6 @@
               <a:rPr lang="en-US" dirty="0"/>
               <a:t>For students and for us: the fundamentals matter more. Writing precise requirements, decomposing problems, designing tests, and having the taste to review architecture and security. The work moves up a level of abstraction — it doesn't go away.</a:t>
             </a:r>
-            <a:endParaRPr lang="en-US" dirty="0"/>
           </a:p>
         </p:txBody>
       </p:sp>
@@ -1000,7 +771,6 @@
               <a:rPr lang="en-US" dirty="0"/>
               <a:t>Be honest: SDD adds ceremony. For a throwaway script just prompt. It pays off when code lives long, more than one person touches it, or you need to explain why it does what it does. Biggest anti-pattern: running all commands back-to-back without reading anything.</a:t>
             </a:r>
-            <a:endParaRPr lang="en-US" dirty="0"/>
           </a:p>
         </p:txBody>
       </p:sp>
@@ -1088,7 +858,6 @@
               <a:rPr lang="en-US" dirty="0"/>
               <a:t>Tool for the demo: GitHub Spec Kit with Gemini CLI — specify init --integration gemini, then /speckit.* slash commands. Switch to terminal. Follow docs/DEMO.md: Act 1 is 8 minutes walking the tags, Act 2 is 6 minutes running a new feature live in Gemini. If the network fails, git checkout solution-002-click-stats.</a:t>
             </a:r>
-            <a:endParaRPr lang="en-US" dirty="0"/>
           </a:p>
         </p:txBody>
       </p:sp>
@@ -1176,7 +945,6 @@
               <a:rPr lang="en-US" dirty="0"/>
               <a:t>Three things to take home. Questions? The repo has every prompt in docs/PROMPTS.md so you can replay it tonight.</a:t>
             </a:r>
-            <a:endParaRPr lang="en-US" dirty="0"/>
           </a:p>
         </p:txBody>
       </p:sp>
@@ -1264,7 +1032,6 @@
               <a:rPr lang="en-US" dirty="0"/>
               <a:t>Raise hands: who has asked an agent for a feature, got 500 lines, and then rewrote half of it? The problem isn't the model, it's that intent was never written down. The agent fills every gap with a guess, and nobody can tell later why a line exists.</a:t>
             </a:r>
-            <a:endParaRPr lang="en-US" dirty="0"/>
           </a:p>
         </p:txBody>
       </p:sp>
@@ -1352,7 +1119,6 @@
               <a:rPr lang="en-US" dirty="0"/>
               <a:t>SDD: you write the what and why first, in a structured spec. The agent derives plan, tasks and code from it. When requirements change, you change the spec and regenerate. The spec is executable intent.</a:t>
             </a:r>
-            <a:endParaRPr lang="en-US" dirty="0"/>
           </a:p>
         </p:txBody>
       </p:sp>
@@ -1440,7 +1206,6 @@
               <a:rPr lang="en-US" dirty="0"/>
               <a:t>SDD isn't one thing. Birgitta Böckeler (Thoughtworks) describes three levels. Spec-first: write a spec to guide a task, maybe discard it. Spec-anchored: the spec stays in the repo and evolves with the feature — that's what the demo shows. Spec-as-source: you only ever edit the spec and regenerate code; promising, but still emerging. Most teams should aim for level 2.</a:t>
             </a:r>
-            <a:endParaRPr lang="en-US" dirty="0"/>
           </a:p>
         </p:txBody>
       </p:sp>
@@ -1528,7 +1293,6 @@
               <a:rPr lang="en-US" dirty="0"/>
               <a:t>A good spec has five parts. Intent, so the agent knows why. Scenarios in Given/When/Then — these become your tests almost mechanically. Requirements with IDs so you can trace them. Success criteria that are measurable. And boundaries: what's out of scope and what's still unknown. Notice what's missing: no frameworks, no databases.</a:t>
             </a:r>
-            <a:endParaRPr lang="en-US" dirty="0"/>
           </a:p>
         </p:txBody>
       </p:sp>
@@ -1616,7 +1380,6 @@
               <a:rPr lang="en-US" dirty="0"/>
               <a:t>Left: what most of us type into a chat. 'Fast' and 'secure' mean nothing to an agent, and the tech choice is mixed into the requirement. Right: one story with an acceptance scenario, a precise rule, a number, and — importantly — an explicit open question. An agent can't guess wrong on something that's written down.</a:t>
             </a:r>
-            <a:endParaRPr lang="en-US" dirty="0"/>
           </a:p>
         </p:txBody>
       </p:sp>
@@ -1704,7 +1467,6 @@
               <a:rPr lang="en-US" dirty="0"/>
               <a:t>Tool-agnostic loop. Specify the what, plan the how, break it into tasks, implement, verify against acceptance criteria. When requirements change you don't patch code — you go back to the spec. If code and spec disagree, that's a bug in one of them, and you decide which.</a:t>
             </a:r>
-            <a:endParaRPr lang="en-US" dirty="0"/>
           </a:p>
         </p:txBody>
       </p:sp>
@@ -1792,7 +1554,6 @@
               <a:rPr lang="en-US" dirty="0"/>
               <a:t>In a few years we went from tab-completion, to chat that writes a function you paste, to agents that take a task, edit many files, run the tests and iterate. Look at the bottom row: our job moved from typing, to pasting, to defining and reviewing. That shift is what 'agentic engineering' means.</a:t>
             </a:r>
-            <a:endParaRPr lang="en-US" dirty="0"/>
           </a:p>
         </p:txBody>
       </p:sp>
@@ -1880,7 +1641,6 @@
               <a:rPr lang="en-US" dirty="0"/>
               <a:t>Demystify it: an agent is a language model in a loop. It plans, calls a tool — shell, file edit, test runner — reads the result, and repeats until it believes the goal is met. 'Believes' is the key word. Its output is only as good as the context you give it and the feedback signals, like tests, it gets back.</a:t>
             </a:r>
-            <a:endParaRPr lang="en-US" dirty="0"/>
           </a:p>
         </p:txBody>
       </p:sp>
@@ -1958,6 +1718,7 @@
         <a:solidFill>
           <a:schemeClr val="tx1"/>
         </a:solidFill>
+        <a:effectLst/>
       </p:bgPr>
     </p:bg>
     <p:spTree>
@@ -1977,9 +1738,11 @@
       <p:sp>
         <p:nvSpPr>
           <p:cNvPr id="2" name="Text 0"/>
-          <p:cNvSpPr/>
+          <p:cNvSpPr>
+            <a:spLocks noGrp="1"/>
+          </p:cNvSpPr>
           <p:nvPr>
-            <p:ph idx="100" type="title" hasCustomPrompt="1"/>
+            <p:ph type="title" idx="100" hasCustomPrompt="1"/>
           </p:nvPr>
         </p:nvSpPr>
         <p:spPr>
@@ -1996,7 +1759,7 @@
         <p:txBody>
           <a:bodyPr wrap="square" rtlCol="0"/>
           <a:lstStyle>
-            <a:lvl1pPr algn="l" indent="0" marL="0">
+            <a:lvl1pPr marL="0" indent="0" algn="l">
               <a:buNone/>
               <a:defRPr lang="en-US" sz="4000" b="1" dirty="0">
                 <a:solidFill>
@@ -2006,7 +1769,7 @@
             </a:lvl1pPr>
           </a:lstStyle>
           <a:p>
-            <a:pPr algn="l" indent="0" marL="0">
+            <a:pPr marL="0" indent="0" algn="l">
               <a:buNone/>
             </a:pPr>
             <a:endParaRPr lang="en-US" sz="4000" dirty="0"/>
@@ -2016,9 +1779,11 @@
       <p:sp>
         <p:nvSpPr>
           <p:cNvPr id="3" name="Text 0"/>
-          <p:cNvSpPr/>
+          <p:cNvSpPr>
+            <a:spLocks noGrp="1"/>
+          </p:cNvSpPr>
           <p:nvPr>
-            <p:ph idx="101" type="body" hasCustomPrompt="1"/>
+            <p:ph type="body" idx="101" hasCustomPrompt="1"/>
           </p:nvPr>
         </p:nvSpPr>
         <p:spPr>
@@ -2035,7 +1800,7 @@
         <p:txBody>
           <a:bodyPr wrap="square" rtlCol="0"/>
           <a:lstStyle>
-            <a:lvl1pPr algn="l" indent="0" marL="0">
+            <a:lvl1pPr marL="0" indent="0" algn="l">
               <a:buNone/>
               <a:defRPr lang="en-US" sz="1800" dirty="0">
                 <a:solidFill>
@@ -2045,7 +1810,7 @@
             </a:lvl1pPr>
           </a:lstStyle>
           <a:p>
-            <a:pPr algn="l" indent="0" marL="0">
+            <a:pPr marL="0" indent="0" algn="l">
               <a:buNone/>
             </a:pPr>
             <a:endParaRPr lang="en-US" sz="1800" dirty="0"/>
@@ -2068,6 +1833,7 @@
         <a:solidFill>
           <a:schemeClr val="tx1"/>
         </a:solidFill>
+        <a:effectLst/>
       </p:bgPr>
     </p:bg>
     <p:spTree>
@@ -2087,9 +1853,11 @@
       <p:sp>
         <p:nvSpPr>
           <p:cNvPr id="2" name="Text 0"/>
-          <p:cNvSpPr/>
+          <p:cNvSpPr>
+            <a:spLocks noGrp="1"/>
+          </p:cNvSpPr>
           <p:nvPr>
-            <p:ph idx="100" type="title" hasCustomPrompt="1"/>
+            <p:ph type="title" idx="100" hasCustomPrompt="1"/>
           </p:nvPr>
         </p:nvSpPr>
         <p:spPr>
@@ -2106,7 +1874,7 @@
         <p:txBody>
           <a:bodyPr wrap="square" rtlCol="0"/>
           <a:lstStyle>
-            <a:lvl1pPr indent="0" marL="0">
+            <a:lvl1pPr marL="0" indent="0">
               <a:buNone/>
               <a:defRPr lang="en-US" sz="3400" b="1" dirty="0">
                 <a:solidFill>
@@ -2116,7 +1884,7 @@
             </a:lvl1pPr>
           </a:lstStyle>
           <a:p>
-            <a:pPr indent="0" marL="0">
+            <a:pPr marL="0" indent="0">
               <a:buNone/>
             </a:pPr>
             <a:endParaRPr lang="en-US" sz="3400" dirty="0"/>
@@ -2144,7 +1912,7 @@
           <a:bodyPr wrap="square" lIns="0" tIns="0" rIns="0" bIns="0" rtlCol="0" anchor="ctr"/>
           <a:lstStyle/>
           <a:p>
-            <a:pPr indent="0" marL="0">
+            <a:pPr marL="0" indent="0">
               <a:buNone/>
             </a:pPr>
             <a:r>
@@ -2179,7 +1947,7 @@
           </a:prstGeom>
           <a:extLst>
             <a:ext uri="{C572A759-6A51-4108-AA02-DFA0A04FC94B}">
-              <ma14:wrappingTextBoxFlag xmlns:ma14="http://schemas.microsoft.com/office/mac/drawingml/2011/main" val="0"/>
+              <ma14:wrappingTextBoxFlag xmlns:ma14="http://schemas.microsoft.com/office/mac/drawingml/2011/main" xmlns="" val="0"/>
             </a:ext>
           </a:extLst>
         </p:spPr>
@@ -2197,8 +1965,8 @@
           <a:p>
             <a:pPr algn="r"/>
             <a:fld id="{F7021451-1387-4CA6-816F-3879F97B5CBC}" type="slidenum">
-              <a:rPr b="0" lang="en-US"/>
-              <a:t>1003</a:t>
+              <a:rPr lang="en-US" b="0"/>
+              <a:t>‹#›</a:t>
             </a:fld>
             <a:endParaRPr lang="en-US"/>
           </a:p>
@@ -2220,6 +1988,7 @@
         <a:solidFill>
           <a:schemeClr val="bg1"/>
         </a:solidFill>
+        <a:effectLst/>
       </p:bgPr>
     </p:bg>
     <p:spTree>
@@ -2239,9 +2008,11 @@
       <p:sp>
         <p:nvSpPr>
           <p:cNvPr id="2" name="Text 0"/>
-          <p:cNvSpPr/>
+          <p:cNvSpPr>
+            <a:spLocks noGrp="1"/>
+          </p:cNvSpPr>
           <p:nvPr>
-            <p:ph idx="100" type="title" hasCustomPrompt="1"/>
+            <p:ph type="title" idx="100" hasCustomPrompt="1"/>
           </p:nvPr>
         </p:nvSpPr>
         <p:spPr>
@@ -2258,7 +2029,7 @@
         <p:txBody>
           <a:bodyPr wrap="square" rtlCol="0"/>
           <a:lstStyle>
-            <a:lvl1pPr indent="0" marL="0">
+            <a:lvl1pPr marL="0" indent="0">
               <a:buNone/>
               <a:defRPr lang="en-US" sz="3200" b="1" dirty="0">
                 <a:solidFill>
@@ -2268,7 +2039,7 @@
             </a:lvl1pPr>
           </a:lstStyle>
           <a:p>
-            <a:pPr indent="0" marL="0">
+            <a:pPr marL="0" indent="0">
               <a:buNone/>
             </a:pPr>
             <a:endParaRPr lang="en-US" sz="3200" dirty="0"/>
@@ -2296,7 +2067,7 @@
           <a:bodyPr wrap="square" lIns="0" tIns="0" rIns="0" bIns="0" rtlCol="0" anchor="ctr"/>
           <a:lstStyle/>
           <a:p>
-            <a:pPr indent="0" marL="0">
+            <a:pPr marL="0" indent="0">
               <a:buNone/>
             </a:pPr>
             <a:r>
@@ -2331,7 +2102,7 @@
           </a:prstGeom>
           <a:extLst>
             <a:ext uri="{C572A759-6A51-4108-AA02-DFA0A04FC94B}">
-              <ma14:wrappingTextBoxFlag xmlns:ma14="http://schemas.microsoft.com/office/mac/drawingml/2011/main" val="0"/>
+              <ma14:wrappingTextBoxFlag xmlns:ma14="http://schemas.microsoft.com/office/mac/drawingml/2011/main" xmlns="" val="0"/>
             </a:ext>
           </a:extLst>
         </p:spPr>
@@ -2349,8 +2120,8 @@
           <a:p>
             <a:pPr algn="r"/>
             <a:fld id="{F7021451-1387-4CA6-816F-3879F97B5CBC}" type="slidenum">
-              <a:rPr b="0" lang="en-US"/>
-              <a:t>1004</a:t>
+              <a:rPr lang="en-US" b="0"/>
+              <a:t>‹#›</a:t>
             </a:fld>
             <a:endParaRPr lang="en-US"/>
           </a:p>
@@ -2367,6 +2138,11 @@
 <file path=ppt/slideMasters/slideMaster1.xml><?xml version="1.0" encoding="utf-8"?>
 <p:sldMaster xmlns:a="http://schemas.openxmlformats.org/drawingml/2006/main" xmlns:r="http://schemas.openxmlformats.org/officeDocument/2006/relationships" xmlns:p="http://schemas.openxmlformats.org/presentationml/2006/main">
   <p:cSld>
+    <p:bg>
+      <p:bgRef idx="1001">
+        <a:schemeClr val="bg1"/>
+      </p:bgRef>
+    </p:bg>
     <p:spTree>
       <p:nvGrpSpPr>
         <p:cNvPr id="1" name=""/>
@@ -2401,7 +2177,7 @@
           </a:prstGeom>
           <a:extLst>
             <a:ext uri="{C572A759-6A51-4108-AA02-DFA0A04FC94B}">
-              <ma14:wrappingTextBoxFlag xmlns:ma14="http://schemas.microsoft.com/office/mac/drawingml/2011/main" val="0"/>
+              <ma14:wrappingTextBoxFlag xmlns:ma14="http://schemas.microsoft.com/office/mac/drawingml/2011/main" xmlns="" val="0"/>
             </a:ext>
           </a:extLst>
         </p:spPr>
@@ -2419,8 +2195,8 @@
           <a:p>
             <a:pPr algn="r"/>
             <a:fld id="{F7021451-1387-4CA6-816F-3879F97B5CBC}" type="slidenum">
-              <a:rPr b="0" lang="en-US"/>
-              <a:t>null</a:t>
+              <a:rPr lang="en-US" b="0"/>
+              <a:t>‹#›</a:t>
             </a:fld>
             <a:endParaRPr lang="en-US"/>
           </a:p>
@@ -2727,11 +2503,11 @@
           <a:bodyPr wrap="square" lIns="0" tIns="0" rIns="0" bIns="0" rtlCol="0" anchor="ctr"/>
           <a:lstStyle/>
           <a:p>
-            <a:pPr indent="0" marL="0">
-              <a:buNone/>
-            </a:pPr>
-            <a:r>
-              <a:rPr lang="en-US" sz="1200" b="1" spc="300" kern="0" dirty="0">
+            <a:pPr marL="0" indent="0">
+              <a:buNone/>
+            </a:pPr>
+            <a:r>
+              <a:rPr lang="en-US" sz="1200" b="1" kern="0" spc="300" dirty="0">
                 <a:solidFill>
                   <a:schemeClr val="accent2"/>
                 </a:solidFill>
@@ -2745,9 +2521,11 @@
       <p:sp>
         <p:nvSpPr>
           <p:cNvPr id="3" name="Text 0"/>
-          <p:cNvSpPr/>
+          <p:cNvSpPr>
+            <a:spLocks noGrp="1"/>
+          </p:cNvSpPr>
           <p:nvPr>
-            <p:ph idx="100" type="title" hasCustomPrompt="1"/>
+            <p:ph type="title" idx="100" hasCustomPrompt="1"/>
           </p:nvPr>
         </p:nvSpPr>
         <p:spPr>
@@ -2765,7 +2543,7 @@
           <a:bodyPr wrap="square" lIns="0" tIns="0" rIns="0" bIns="0" rtlCol="0" anchor="b"/>
           <a:lstStyle/>
           <a:p>
-            <a:pPr algn="l" indent="0" marL="0">
+            <a:pPr marL="0" indent="0" algn="l">
               <a:buNone/>
             </a:pPr>
             <a:r>
@@ -2783,9 +2561,11 @@
       <p:sp>
         <p:nvSpPr>
           <p:cNvPr id="4" name="Text 0"/>
-          <p:cNvSpPr/>
+          <p:cNvSpPr>
+            <a:spLocks noGrp="1"/>
+          </p:cNvSpPr>
           <p:nvPr>
-            <p:ph idx="101" type="body" hasCustomPrompt="1"/>
+            <p:ph type="body" idx="101" hasCustomPrompt="1"/>
           </p:nvPr>
         </p:nvSpPr>
         <p:spPr>
@@ -2803,7 +2583,7 @@
           <a:bodyPr wrap="square" lIns="0" tIns="0" rIns="0" bIns="0" rtlCol="0" anchor="t"/>
           <a:lstStyle/>
           <a:p>
-            <a:pPr algn="l" indent="0" marL="0">
+            <a:pPr marL="0" indent="0" algn="l">
               <a:buNone/>
             </a:pPr>
             <a:r>
@@ -2839,7 +2619,7 @@
           <a:bodyPr wrap="square" lIns="0" tIns="0" rIns="0" bIns="0" rtlCol="0" anchor="ctr"/>
           <a:lstStyle/>
           <a:p>
-            <a:pPr indent="0" marL="0">
+            <a:pPr marL="0" indent="0">
               <a:buNone/>
             </a:pPr>
             <a:r>
@@ -2856,14 +2636,14 @@
       </p:sp>
       <p:pic>
         <p:nvPicPr>
-          <p:cNvPr id="6" name="hero" descr="img/hero.png">    </p:cNvPr>
+          <p:cNvPr id="6" name="hero" descr="img/hero.png"/>
           <p:cNvPicPr>
             <a:picLocks noChangeAspect="1"/>
           </p:cNvPicPr>
           <p:nvPr/>
         </p:nvPicPr>
         <p:blipFill>
-          <a:blip r:embed="rId1"/>
+          <a:blip r:embed="rId3"/>
           <a:stretch>
             <a:fillRect/>
           </a:stretch>
@@ -2906,9 +2686,11 @@
       <p:sp>
         <p:nvSpPr>
           <p:cNvPr id="2" name="Text 0"/>
-          <p:cNvSpPr/>
+          <p:cNvSpPr>
+            <a:spLocks noGrp="1"/>
+          </p:cNvSpPr>
           <p:nvPr>
-            <p:ph idx="100" type="title" hasCustomPrompt="1"/>
+            <p:ph type="title" idx="100" hasCustomPrompt="1"/>
           </p:nvPr>
         </p:nvSpPr>
         <p:spPr>
@@ -2926,7 +2708,7 @@
           <a:bodyPr wrap="square" lIns="0" tIns="0" rIns="0" bIns="0" rtlCol="0" anchor="ctr"/>
           <a:lstStyle/>
           <a:p>
-            <a:pPr indent="0" marL="0">
+            <a:pPr marL="0" indent="0">
               <a:buNone/>
             </a:pPr>
             <a:r>
@@ -2965,17 +2747,24 @@
             <a:prstDash val="solid"/>
           </a:ln>
         </p:spPr>
+        <p:txBody>
+          <a:bodyPr/>
+          <a:lstStyle/>
+          <a:p>
+            <a:endParaRPr lang="en-CR"/>
+          </a:p>
+        </p:txBody>
       </p:sp>
       <p:pic>
         <p:nvPicPr>
-          <p:cNvPr id="4" name="icon-FaUserAstronaut" descr="preencoded.png">    </p:cNvPr>
+          <p:cNvPr id="4" name="icon-FaUserAstronaut" descr="preencoded.png"/>
           <p:cNvPicPr>
             <a:picLocks noChangeAspect="1"/>
           </p:cNvPicPr>
           <p:nvPr/>
         </p:nvPicPr>
         <p:blipFill>
-          <a:blip r:embed="rId1"/>
+          <a:blip r:embed="rId3"/>
           <a:stretch>
             <a:fillRect/>
           </a:stretch>
@@ -3014,17 +2803,24 @@
             <a:prstDash val="solid"/>
           </a:ln>
         </p:spPr>
+        <p:txBody>
+          <a:bodyPr/>
+          <a:lstStyle/>
+          <a:p>
+            <a:endParaRPr lang="en-CR"/>
+          </a:p>
+        </p:txBody>
       </p:sp>
       <p:pic>
         <p:nvPicPr>
-          <p:cNvPr id="6" name="icon-FaRobot" descr="preencoded.png">    </p:cNvPr>
+          <p:cNvPr id="6" name="icon-FaRobot" descr="preencoded.png"/>
           <p:cNvPicPr>
             <a:picLocks noChangeAspect="1"/>
           </p:cNvPicPr>
           <p:nvPr/>
         </p:nvPicPr>
         <p:blipFill>
-          <a:blip r:embed="rId2"/>
+          <a:blip r:embed="rId4"/>
           <a:stretch>
             <a:fillRect/>
           </a:stretch>
@@ -3060,7 +2856,7 @@
           <a:bodyPr wrap="square" lIns="0" tIns="0" rIns="0" bIns="0" rtlCol="0" anchor="ctr"/>
           <a:lstStyle/>
           <a:p>
-            <a:pPr indent="0" marL="0">
+            <a:pPr marL="0" indent="0">
               <a:buNone/>
             </a:pPr>
             <a:r>
@@ -3096,7 +2892,7 @@
           <a:bodyPr wrap="square" lIns="0" tIns="0" rIns="0" bIns="0" rtlCol="0" anchor="ctr"/>
           <a:lstStyle/>
           <a:p>
-            <a:pPr algn="r" indent="0" marL="0">
+            <a:pPr marL="0" indent="0" algn="r">
               <a:buNone/>
             </a:pPr>
             <a:r>
@@ -3325,6 +3121,13 @@
             <a:prstDash val="solid"/>
           </a:ln>
         </p:spPr>
+        <p:txBody>
+          <a:bodyPr/>
+          <a:lstStyle/>
+          <a:p>
+            <a:endParaRPr lang="en-CR"/>
+          </a:p>
+        </p:txBody>
       </p:sp>
       <p:sp>
         <p:nvSpPr>
@@ -3347,7 +3150,7 @@
           <a:bodyPr wrap="square" lIns="0" tIns="0" rIns="0" bIns="0" rtlCol="0" anchor="ctr"/>
           <a:lstStyle/>
           <a:p>
-            <a:pPr algn="ctr" indent="0" marL="0">
+            <a:pPr marL="0" indent="0" algn="ctr">
               <a:buNone/>
             </a:pPr>
             <a:r>
@@ -3391,6 +3194,13 @@
             <a:prstDash val="solid"/>
           </a:ln>
         </p:spPr>
+        <p:txBody>
+          <a:bodyPr/>
+          <a:lstStyle/>
+          <a:p>
+            <a:endParaRPr lang="en-CR"/>
+          </a:p>
+        </p:txBody>
       </p:sp>
       <p:sp>
         <p:nvSpPr>
@@ -3413,7 +3223,7 @@
           <a:bodyPr wrap="square" lIns="0" tIns="0" rIns="0" bIns="0" rtlCol="0" anchor="ctr"/>
           <a:lstStyle/>
           <a:p>
-            <a:pPr algn="ctr" indent="0" marL="0">
+            <a:pPr marL="0" indent="0" algn="ctr">
               <a:buNone/>
             </a:pPr>
             <a:r>
@@ -3457,6 +3267,13 @@
             <a:prstDash val="solid"/>
           </a:ln>
         </p:spPr>
+        <p:txBody>
+          <a:bodyPr/>
+          <a:lstStyle/>
+          <a:p>
+            <a:endParaRPr lang="en-CR"/>
+          </a:p>
+        </p:txBody>
       </p:sp>
       <p:sp>
         <p:nvSpPr>
@@ -3479,7 +3296,7 @@
           <a:bodyPr wrap="square" lIns="0" tIns="0" rIns="0" bIns="0" rtlCol="0" anchor="ctr"/>
           <a:lstStyle/>
           <a:p>
-            <a:pPr algn="ctr" indent="0" marL="0">
+            <a:pPr marL="0" indent="0" algn="ctr">
               <a:buNone/>
             </a:pPr>
             <a:r>
@@ -3523,6 +3340,13 @@
             <a:prstDash val="solid"/>
           </a:ln>
         </p:spPr>
+        <p:txBody>
+          <a:bodyPr/>
+          <a:lstStyle/>
+          <a:p>
+            <a:endParaRPr lang="en-CR"/>
+          </a:p>
+        </p:txBody>
       </p:sp>
       <p:sp>
         <p:nvSpPr>
@@ -3545,7 +3369,7 @@
           <a:bodyPr wrap="square" lIns="0" tIns="0" rIns="0" bIns="0" rtlCol="0" anchor="ctr"/>
           <a:lstStyle/>
           <a:p>
-            <a:pPr algn="ctr" indent="0" marL="0">
+            <a:pPr marL="0" indent="0" algn="ctr">
               <a:buNone/>
             </a:pPr>
             <a:r>
@@ -3583,7 +3407,7 @@
           </a:prstGeom>
           <a:extLst>
             <a:ext uri="{C572A759-6A51-4108-AA02-DFA0A04FC94B}">
-              <ma14:wrappingTextBoxFlag xmlns:ma14="http://schemas.microsoft.com/office/mac/drawingml/2011/main" val="0"/>
+              <ma14:wrappingTextBoxFlag xmlns:ma14="http://schemas.microsoft.com/office/mac/drawingml/2011/main" xmlns="" val="0"/>
             </a:ext>
           </a:extLst>
         </p:spPr>
@@ -3601,7 +3425,7 @@
           <a:p>
             <a:pPr algn="r"/>
             <a:fld id="{F7021451-1387-4CA6-816F-3879F97B5CBC}" type="slidenum">
-              <a:rPr b="0" lang="en-US"/>
+              <a:rPr lang="en-US" b="0"/>
               <a:t>10</a:t>
             </a:fld>
             <a:endParaRPr lang="en-US"/>
@@ -3636,9 +3460,11 @@
       <p:sp>
         <p:nvSpPr>
           <p:cNvPr id="2" name="Text 0"/>
-          <p:cNvSpPr/>
+          <p:cNvSpPr>
+            <a:spLocks noGrp="1"/>
+          </p:cNvSpPr>
           <p:nvPr>
-            <p:ph idx="100" type="title" hasCustomPrompt="1"/>
+            <p:ph type="title" idx="100" hasCustomPrompt="1"/>
           </p:nvPr>
         </p:nvSpPr>
         <p:spPr>
@@ -3656,7 +3482,7 @@
           <a:bodyPr wrap="square" lIns="0" tIns="0" rIns="0" bIns="0" rtlCol="0" anchor="ctr"/>
           <a:lstStyle/>
           <a:p>
-            <a:pPr indent="0" marL="0">
+            <a:pPr marL="0" indent="0">
               <a:buNone/>
             </a:pPr>
             <a:r>
@@ -3697,6 +3523,13 @@
             <a:prstDash val="solid"/>
           </a:ln>
         </p:spPr>
+        <p:txBody>
+          <a:bodyPr/>
+          <a:lstStyle/>
+          <a:p>
+            <a:endParaRPr lang="en-CR"/>
+          </a:p>
+        </p:txBody>
       </p:sp>
       <p:sp>
         <p:nvSpPr>
@@ -3719,7 +3552,7 @@
           <a:bodyPr wrap="square" lIns="0" tIns="0" rIns="0" bIns="0" rtlCol="0" anchor="ctr"/>
           <a:lstStyle/>
           <a:p>
-            <a:pPr algn="ctr" indent="0" marL="0">
+            <a:pPr marL="0" indent="0" algn="ctr">
               <a:buNone/>
             </a:pPr>
             <a:r>
@@ -3730,9 +3563,6 @@
               </a:rPr>
               <a:t>Rules / constitution</a:t>
             </a:r>
-            <a:pPr algn="ctr" indent="0" marL="0">
-              <a:buNone/>
-            </a:pPr>
             <a:r>
               <a:rPr lang="en-US" sz="1500" dirty="0">
                 <a:solidFill>
@@ -3771,6 +3601,13 @@
             <a:prstDash val="solid"/>
           </a:ln>
         </p:spPr>
+        <p:txBody>
+          <a:bodyPr/>
+          <a:lstStyle/>
+          <a:p>
+            <a:endParaRPr lang="en-CR"/>
+          </a:p>
+        </p:txBody>
       </p:sp>
       <p:sp>
         <p:nvSpPr>
@@ -3793,7 +3630,7 @@
           <a:bodyPr wrap="square" lIns="0" tIns="0" rIns="0" bIns="0" rtlCol="0" anchor="ctr"/>
           <a:lstStyle/>
           <a:p>
-            <a:pPr algn="ctr" indent="0" marL="0">
+            <a:pPr marL="0" indent="0" algn="ctr">
               <a:buNone/>
             </a:pPr>
             <a:r>
@@ -3804,9 +3641,6 @@
               </a:rPr>
               <a:t>Spec</a:t>
             </a:r>
-            <a:pPr algn="ctr" indent="0" marL="0">
-              <a:buNone/>
-            </a:pPr>
             <a:r>
               <a:rPr lang="en-US" sz="1500" dirty="0">
                 <a:solidFill>
@@ -3845,6 +3679,13 @@
             <a:prstDash val="solid"/>
           </a:ln>
         </p:spPr>
+        <p:txBody>
+          <a:bodyPr/>
+          <a:lstStyle/>
+          <a:p>
+            <a:endParaRPr lang="en-CR"/>
+          </a:p>
+        </p:txBody>
       </p:sp>
       <p:sp>
         <p:nvSpPr>
@@ -3867,7 +3708,7 @@
           <a:bodyPr wrap="square" lIns="0" tIns="0" rIns="0" bIns="0" rtlCol="0" anchor="ctr"/>
           <a:lstStyle/>
           <a:p>
-            <a:pPr algn="ctr" indent="0" marL="0">
+            <a:pPr marL="0" indent="0" algn="ctr">
               <a:buNone/>
             </a:pPr>
             <a:r>
@@ -3878,9 +3719,6 @@
               </a:rPr>
               <a:t>Plan</a:t>
             </a:r>
-            <a:pPr algn="ctr" indent="0" marL="0">
-              <a:buNone/>
-            </a:pPr>
             <a:r>
               <a:rPr lang="en-US" sz="1500" dirty="0">
                 <a:solidFill>
@@ -3919,6 +3757,13 @@
             <a:prstDash val="solid"/>
           </a:ln>
         </p:spPr>
+        <p:txBody>
+          <a:bodyPr/>
+          <a:lstStyle/>
+          <a:p>
+            <a:endParaRPr lang="en-CR"/>
+          </a:p>
+        </p:txBody>
       </p:sp>
       <p:sp>
         <p:nvSpPr>
@@ -3941,7 +3786,7 @@
           <a:bodyPr wrap="square" lIns="0" tIns="0" rIns="0" bIns="0" rtlCol="0" anchor="ctr"/>
           <a:lstStyle/>
           <a:p>
-            <a:pPr algn="ctr" indent="0" marL="0">
+            <a:pPr marL="0" indent="0" algn="ctr">
               <a:buNone/>
             </a:pPr>
             <a:r>
@@ -3952,9 +3797,6 @@
               </a:rPr>
               <a:t>Tasks</a:t>
             </a:r>
-            <a:pPr algn="ctr" indent="0" marL="0">
-              <a:buNone/>
-            </a:pPr>
             <a:r>
               <a:rPr lang="en-US" sz="1500" dirty="0">
                 <a:solidFill>
@@ -3993,6 +3835,13 @@
             <a:prstDash val="solid"/>
           </a:ln>
         </p:spPr>
+        <p:txBody>
+          <a:bodyPr/>
+          <a:lstStyle/>
+          <a:p>
+            <a:endParaRPr lang="en-CR"/>
+          </a:p>
+        </p:txBody>
       </p:sp>
       <p:sp>
         <p:nvSpPr>
@@ -4015,7 +3864,7 @@
           <a:bodyPr wrap="square" lIns="0" tIns="0" rIns="0" bIns="0" rtlCol="0" anchor="ctr"/>
           <a:lstStyle/>
           <a:p>
-            <a:pPr algn="ctr" indent="0" marL="0">
+            <a:pPr marL="0" indent="0" algn="ctr">
               <a:buNone/>
             </a:pPr>
             <a:r>
@@ -4026,9 +3875,6 @@
               </a:rPr>
               <a:t>Code &amp; tests</a:t>
             </a:r>
-            <a:pPr algn="ctr" indent="0" marL="0">
-              <a:buNone/>
-            </a:pPr>
             <a:r>
               <a:rPr lang="en-US" sz="1500" dirty="0">
                 <a:solidFill>
@@ -4077,12 +3923,6 @@
               </a:rPr>
               <a:t>Files, not chat</a:t>
             </a:r>
-            <a:pPr indent="0" marL="0">
-              <a:spcAft>
-                <a:spcPts val="1000"/>
-              </a:spcAft>
-              <a:buNone/>
-            </a:pPr>
             <a:r>
               <a:rPr lang="en-US" sz="1500" dirty="0">
                 <a:solidFill>
@@ -4109,12 +3949,6 @@
               </a:rPr>
               <a:t>Small &amp; relevant</a:t>
             </a:r>
-            <a:pPr indent="0" marL="0">
-              <a:spcAft>
-                <a:spcPts val="1000"/>
-              </a:spcAft>
-              <a:buNone/>
-            </a:pPr>
             <a:r>
               <a:rPr lang="en-US" sz="1500" dirty="0">
                 <a:solidFill>
@@ -4141,12 +3975,6 @@
               </a:rPr>
               <a:t>Fresh session</a:t>
             </a:r>
-            <a:pPr indent="0" marL="0">
-              <a:spcAft>
-                <a:spcPts val="1000"/>
-              </a:spcAft>
-              <a:buNone/>
-            </a:pPr>
             <a:r>
               <a:rPr lang="en-US" sz="1500" dirty="0">
                 <a:solidFill>
@@ -4179,7 +4007,7 @@
           </a:prstGeom>
           <a:extLst>
             <a:ext uri="{C572A759-6A51-4108-AA02-DFA0A04FC94B}">
-              <ma14:wrappingTextBoxFlag xmlns:ma14="http://schemas.microsoft.com/office/mac/drawingml/2011/main" val="0"/>
+              <ma14:wrappingTextBoxFlag xmlns:ma14="http://schemas.microsoft.com/office/mac/drawingml/2011/main" xmlns="" val="0"/>
             </a:ext>
           </a:extLst>
         </p:spPr>
@@ -4197,7 +4025,7 @@
           <a:p>
             <a:pPr algn="r"/>
             <a:fld id="{F7021451-1387-4CA6-816F-3879F97B5CBC}" type="slidenum">
-              <a:rPr b="0" lang="en-US"/>
+              <a:rPr lang="en-US" b="0"/>
               <a:t>11</a:t>
             </a:fld>
             <a:endParaRPr lang="en-US"/>
@@ -4232,9 +4060,11 @@
       <p:sp>
         <p:nvSpPr>
           <p:cNvPr id="2" name="Text 0"/>
-          <p:cNvSpPr/>
+          <p:cNvSpPr>
+            <a:spLocks noGrp="1"/>
+          </p:cNvSpPr>
           <p:nvPr>
-            <p:ph idx="100" type="title" hasCustomPrompt="1"/>
+            <p:ph type="title" idx="100" hasCustomPrompt="1"/>
           </p:nvPr>
         </p:nvSpPr>
         <p:spPr>
@@ -4252,7 +4082,7 @@
           <a:bodyPr wrap="square" lIns="0" tIns="0" rIns="0" bIns="0" rtlCol="0" anchor="ctr"/>
           <a:lstStyle/>
           <a:p>
-            <a:pPr indent="0" marL="0">
+            <a:pPr marL="0" indent="0">
               <a:buNone/>
             </a:pPr>
             <a:r>
@@ -4293,6 +4123,13 @@
             <a:prstDash val="solid"/>
           </a:ln>
         </p:spPr>
+        <p:txBody>
+          <a:bodyPr/>
+          <a:lstStyle/>
+          <a:p>
+            <a:endParaRPr lang="en-CR"/>
+          </a:p>
+        </p:txBody>
       </p:sp>
       <p:sp>
         <p:nvSpPr>
@@ -4318,17 +4155,24 @@
             <a:prstDash val="solid"/>
           </a:ln>
         </p:spPr>
+        <p:txBody>
+          <a:bodyPr/>
+          <a:lstStyle/>
+          <a:p>
+            <a:endParaRPr lang="en-CR"/>
+          </a:p>
+        </p:txBody>
       </p:sp>
       <p:pic>
         <p:nvPicPr>
-          <p:cNvPr id="5" name="icon-FaVial" descr="preencoded.png">    </p:cNvPr>
+          <p:cNvPr id="5" name="icon-FaVial" descr="preencoded.png"/>
           <p:cNvPicPr>
             <a:picLocks noChangeAspect="1"/>
           </p:cNvPicPr>
           <p:nvPr/>
         </p:nvPicPr>
         <p:blipFill>
-          <a:blip r:embed="rId1"/>
+          <a:blip r:embed="rId3"/>
           <a:stretch>
             <a:fillRect/>
           </a:stretch>
@@ -4364,7 +4208,7 @@
           <a:bodyPr wrap="square" lIns="0" tIns="0" rIns="0" bIns="0" rtlCol="0" anchor="ctr"/>
           <a:lstStyle/>
           <a:p>
-            <a:pPr indent="0" marL="0">
+            <a:pPr marL="0" indent="0">
               <a:buNone/>
             </a:pPr>
             <a:r>
@@ -4400,7 +4244,7 @@
           <a:bodyPr wrap="square" lIns="0" tIns="0" rIns="0" bIns="0" rtlCol="0" anchor="t"/>
           <a:lstStyle/>
           <a:p>
-            <a:pPr indent="0" marL="0">
+            <a:pPr marL="0" indent="0">
               <a:buNone/>
             </a:pPr>
             <a:r>
@@ -4441,6 +4285,13 @@
             <a:prstDash val="solid"/>
           </a:ln>
         </p:spPr>
+        <p:txBody>
+          <a:bodyPr/>
+          <a:lstStyle/>
+          <a:p>
+            <a:endParaRPr lang="en-CR"/>
+          </a:p>
+        </p:txBody>
       </p:sp>
       <p:sp>
         <p:nvSpPr>
@@ -4466,17 +4317,24 @@
             <a:prstDash val="solid"/>
           </a:ln>
         </p:spPr>
+        <p:txBody>
+          <a:bodyPr/>
+          <a:lstStyle/>
+          <a:p>
+            <a:endParaRPr lang="en-CR"/>
+          </a:p>
+        </p:txBody>
       </p:sp>
       <p:pic>
         <p:nvPicPr>
-          <p:cNvPr id="10" name="icon-FaCompressArrowsAlt" descr="preencoded.png">    </p:cNvPr>
+          <p:cNvPr id="10" name="icon-FaCompressArrowsAlt" descr="preencoded.png"/>
           <p:cNvPicPr>
             <a:picLocks noChangeAspect="1"/>
           </p:cNvPicPr>
           <p:nvPr/>
         </p:nvPicPr>
         <p:blipFill>
-          <a:blip r:embed="rId2"/>
+          <a:blip r:embed="rId4"/>
           <a:stretch>
             <a:fillRect/>
           </a:stretch>
@@ -4512,7 +4370,7 @@
           <a:bodyPr wrap="square" lIns="0" tIns="0" rIns="0" bIns="0" rtlCol="0" anchor="ctr"/>
           <a:lstStyle/>
           <a:p>
-            <a:pPr indent="0" marL="0">
+            <a:pPr marL="0" indent="0">
               <a:buNone/>
             </a:pPr>
             <a:r>
@@ -4548,7 +4406,7 @@
           <a:bodyPr wrap="square" lIns="0" tIns="0" rIns="0" bIns="0" rtlCol="0" anchor="t"/>
           <a:lstStyle/>
           <a:p>
-            <a:pPr indent="0" marL="0">
+            <a:pPr marL="0" indent="0">
               <a:buNone/>
             </a:pPr>
             <a:r>
@@ -4589,6 +4447,13 @@
             <a:prstDash val="solid"/>
           </a:ln>
         </p:spPr>
+        <p:txBody>
+          <a:bodyPr/>
+          <a:lstStyle/>
+          <a:p>
+            <a:endParaRPr lang="en-CR"/>
+          </a:p>
+        </p:txBody>
       </p:sp>
       <p:sp>
         <p:nvSpPr>
@@ -4614,17 +4479,24 @@
             <a:prstDash val="solid"/>
           </a:ln>
         </p:spPr>
+        <p:txBody>
+          <a:bodyPr/>
+          <a:lstStyle/>
+          <a:p>
+            <a:endParaRPr lang="en-CR"/>
+          </a:p>
+        </p:txBody>
       </p:sp>
       <p:pic>
         <p:nvPicPr>
-          <p:cNvPr id="15" name="icon-FaUserCheck" descr="preencoded.png">    </p:cNvPr>
+          <p:cNvPr id="15" name="icon-FaUserCheck" descr="preencoded.png"/>
           <p:cNvPicPr>
             <a:picLocks noChangeAspect="1"/>
           </p:cNvPicPr>
           <p:nvPr/>
         </p:nvPicPr>
         <p:blipFill>
-          <a:blip r:embed="rId3"/>
+          <a:blip r:embed="rId5"/>
           <a:stretch>
             <a:fillRect/>
           </a:stretch>
@@ -4660,7 +4532,7 @@
           <a:bodyPr wrap="square" lIns="0" tIns="0" rIns="0" bIns="0" rtlCol="0" anchor="ctr"/>
           <a:lstStyle/>
           <a:p>
-            <a:pPr indent="0" marL="0">
+            <a:pPr marL="0" indent="0">
               <a:buNone/>
             </a:pPr>
             <a:r>
@@ -4696,7 +4568,7 @@
           <a:bodyPr wrap="square" lIns="0" tIns="0" rIns="0" bIns="0" rtlCol="0" anchor="t"/>
           <a:lstStyle/>
           <a:p>
-            <a:pPr indent="0" marL="0">
+            <a:pPr marL="0" indent="0">
               <a:buNone/>
             </a:pPr>
             <a:r>
@@ -4737,6 +4609,13 @@
             <a:prstDash val="solid"/>
           </a:ln>
         </p:spPr>
+        <p:txBody>
+          <a:bodyPr/>
+          <a:lstStyle/>
+          <a:p>
+            <a:endParaRPr lang="en-CR"/>
+          </a:p>
+        </p:txBody>
       </p:sp>
       <p:sp>
         <p:nvSpPr>
@@ -4762,17 +4641,24 @@
             <a:prstDash val="solid"/>
           </a:ln>
         </p:spPr>
+        <p:txBody>
+          <a:bodyPr/>
+          <a:lstStyle/>
+          <a:p>
+            <a:endParaRPr lang="en-CR"/>
+          </a:p>
+        </p:txBody>
       </p:sp>
       <p:pic>
         <p:nvPicPr>
-          <p:cNvPr id="20" name="icon-FaShieldAlt" descr="preencoded.png">    </p:cNvPr>
+          <p:cNvPr id="20" name="icon-FaShieldAlt" descr="preencoded.png"/>
           <p:cNvPicPr>
             <a:picLocks noChangeAspect="1"/>
           </p:cNvPicPr>
           <p:nvPr/>
         </p:nvPicPr>
         <p:blipFill>
-          <a:blip r:embed="rId4"/>
+          <a:blip r:embed="rId6"/>
           <a:stretch>
             <a:fillRect/>
           </a:stretch>
@@ -4808,7 +4694,7 @@
           <a:bodyPr wrap="square" lIns="0" tIns="0" rIns="0" bIns="0" rtlCol="0" anchor="ctr"/>
           <a:lstStyle/>
           <a:p>
-            <a:pPr indent="0" marL="0">
+            <a:pPr marL="0" indent="0">
               <a:buNone/>
             </a:pPr>
             <a:r>
@@ -4844,7 +4730,7 @@
           <a:bodyPr wrap="square" lIns="0" tIns="0" rIns="0" bIns="0" rtlCol="0" anchor="t"/>
           <a:lstStyle/>
           <a:p>
-            <a:pPr indent="0" marL="0">
+            <a:pPr marL="0" indent="0">
               <a:buNone/>
             </a:pPr>
             <a:r>
@@ -4879,7 +4765,7 @@
           </a:prstGeom>
           <a:extLst>
             <a:ext uri="{C572A759-6A51-4108-AA02-DFA0A04FC94B}">
-              <ma14:wrappingTextBoxFlag xmlns:ma14="http://schemas.microsoft.com/office/mac/drawingml/2011/main" val="0"/>
+              <ma14:wrappingTextBoxFlag xmlns:ma14="http://schemas.microsoft.com/office/mac/drawingml/2011/main" xmlns="" val="0"/>
             </a:ext>
           </a:extLst>
         </p:spPr>
@@ -4897,7 +4783,7 @@
           <a:p>
             <a:pPr algn="r"/>
             <a:fld id="{F7021451-1387-4CA6-816F-3879F97B5CBC}" type="slidenum">
-              <a:rPr b="0" lang="en-US"/>
+              <a:rPr lang="en-US" b="0"/>
               <a:t>12</a:t>
             </a:fld>
             <a:endParaRPr lang="en-US"/>
@@ -4932,9 +4818,11 @@
       <p:sp>
         <p:nvSpPr>
           <p:cNvPr id="2" name="Text 0"/>
-          <p:cNvSpPr/>
+          <p:cNvSpPr>
+            <a:spLocks noGrp="1"/>
+          </p:cNvSpPr>
           <p:nvPr>
-            <p:ph idx="100" type="title" hasCustomPrompt="1"/>
+            <p:ph type="title" idx="100" hasCustomPrompt="1"/>
           </p:nvPr>
         </p:nvSpPr>
         <p:spPr>
@@ -4952,7 +4840,7 @@
           <a:bodyPr wrap="square" lIns="0" tIns="0" rIns="0" bIns="0" rtlCol="0" anchor="ctr"/>
           <a:lstStyle/>
           <a:p>
-            <a:pPr indent="0" marL="0">
+            <a:pPr marL="0" indent="0">
               <a:buNone/>
             </a:pPr>
             <a:r>
@@ -4991,17 +4879,24 @@
             <a:prstDash val="solid"/>
           </a:ln>
         </p:spPr>
+        <p:txBody>
+          <a:bodyPr/>
+          <a:lstStyle/>
+          <a:p>
+            <a:endParaRPr lang="en-CR"/>
+          </a:p>
+        </p:txBody>
       </p:sp>
       <p:pic>
         <p:nvPicPr>
-          <p:cNvPr id="4" name="icon-FaPenNib" descr="preencoded.png">    </p:cNvPr>
+          <p:cNvPr id="4" name="icon-FaPenNib" descr="preencoded.png"/>
           <p:cNvPicPr>
             <a:picLocks noChangeAspect="1"/>
           </p:cNvPicPr>
           <p:nvPr/>
         </p:nvPicPr>
         <p:blipFill>
-          <a:blip r:embed="rId1"/>
+          <a:blip r:embed="rId3"/>
           <a:stretch>
             <a:fillRect/>
           </a:stretch>
@@ -5037,7 +4932,7 @@
           <a:bodyPr wrap="square" lIns="0" tIns="0" rIns="0" bIns="0" rtlCol="0" anchor="ctr"/>
           <a:lstStyle/>
           <a:p>
-            <a:pPr indent="0" marL="0">
+            <a:pPr marL="0" indent="0">
               <a:buNone/>
             </a:pPr>
             <a:r>
@@ -5073,7 +4968,7 @@
           <a:bodyPr wrap="square" lIns="0" tIns="0" rIns="0" bIns="0" rtlCol="0" anchor="ctr"/>
           <a:lstStyle/>
           <a:p>
-            <a:pPr indent="0" marL="0">
+            <a:pPr marL="0" indent="0">
               <a:buNone/>
             </a:pPr>
             <a:r>
@@ -5112,17 +5007,24 @@
             <a:prstDash val="solid"/>
           </a:ln>
         </p:spPr>
+        <p:txBody>
+          <a:bodyPr/>
+          <a:lstStyle/>
+          <a:p>
+            <a:endParaRPr lang="en-CR"/>
+          </a:p>
+        </p:txBody>
       </p:sp>
       <p:pic>
         <p:nvPicPr>
-          <p:cNvPr id="8" name="icon-FaProjectDiagram" descr="preencoded.png">    </p:cNvPr>
+          <p:cNvPr id="8" name="icon-FaProjectDiagram" descr="preencoded.png"/>
           <p:cNvPicPr>
             <a:picLocks noChangeAspect="1"/>
           </p:cNvPicPr>
           <p:nvPr/>
         </p:nvPicPr>
         <p:blipFill>
-          <a:blip r:embed="rId2"/>
+          <a:blip r:embed="rId4"/>
           <a:stretch>
             <a:fillRect/>
           </a:stretch>
@@ -5158,7 +5060,7 @@
           <a:bodyPr wrap="square" lIns="0" tIns="0" rIns="0" bIns="0" rtlCol="0" anchor="ctr"/>
           <a:lstStyle/>
           <a:p>
-            <a:pPr indent="0" marL="0">
+            <a:pPr marL="0" indent="0">
               <a:buNone/>
             </a:pPr>
             <a:r>
@@ -5194,7 +5096,7 @@
           <a:bodyPr wrap="square" lIns="0" tIns="0" rIns="0" bIns="0" rtlCol="0" anchor="ctr"/>
           <a:lstStyle/>
           <a:p>
-            <a:pPr indent="0" marL="0">
+            <a:pPr marL="0" indent="0">
               <a:buNone/>
             </a:pPr>
             <a:r>
@@ -5233,17 +5135,24 @@
             <a:prstDash val="solid"/>
           </a:ln>
         </p:spPr>
+        <p:txBody>
+          <a:bodyPr/>
+          <a:lstStyle/>
+          <a:p>
+            <a:endParaRPr lang="en-CR"/>
+          </a:p>
+        </p:txBody>
       </p:sp>
       <p:pic>
         <p:nvPicPr>
-          <p:cNvPr id="12" name="icon-FaClipboardCheck" descr="preencoded.png">    </p:cNvPr>
+          <p:cNvPr id="12" name="icon-FaClipboardCheck" descr="preencoded.png"/>
           <p:cNvPicPr>
             <a:picLocks noChangeAspect="1"/>
           </p:cNvPicPr>
           <p:nvPr/>
         </p:nvPicPr>
         <p:blipFill>
-          <a:blip r:embed="rId3"/>
+          <a:blip r:embed="rId5"/>
           <a:stretch>
             <a:fillRect/>
           </a:stretch>
@@ -5279,7 +5188,7 @@
           <a:bodyPr wrap="square" lIns="0" tIns="0" rIns="0" bIns="0" rtlCol="0" anchor="ctr"/>
           <a:lstStyle/>
           <a:p>
-            <a:pPr indent="0" marL="0">
+            <a:pPr marL="0" indent="0">
               <a:buNone/>
             </a:pPr>
             <a:r>
@@ -5315,7 +5224,7 @@
           <a:bodyPr wrap="square" lIns="0" tIns="0" rIns="0" bIns="0" rtlCol="0" anchor="ctr"/>
           <a:lstStyle/>
           <a:p>
-            <a:pPr indent="0" marL="0">
+            <a:pPr marL="0" indent="0">
               <a:buNone/>
             </a:pPr>
             <a:r>
@@ -5354,17 +5263,24 @@
             <a:prstDash val="solid"/>
           </a:ln>
         </p:spPr>
+        <p:txBody>
+          <a:bodyPr/>
+          <a:lstStyle/>
+          <a:p>
+            <a:endParaRPr lang="en-CR"/>
+          </a:p>
+        </p:txBody>
       </p:sp>
       <p:pic>
         <p:nvPicPr>
-          <p:cNvPr id="16" name="icon-FaEye" descr="preencoded.png">    </p:cNvPr>
+          <p:cNvPr id="16" name="icon-FaEye" descr="preencoded.png"/>
           <p:cNvPicPr>
             <a:picLocks noChangeAspect="1"/>
           </p:cNvPicPr>
           <p:nvPr/>
         </p:nvPicPr>
         <p:blipFill>
-          <a:blip r:embed="rId4"/>
+          <a:blip r:embed="rId6"/>
           <a:stretch>
             <a:fillRect/>
           </a:stretch>
@@ -5400,7 +5316,7 @@
           <a:bodyPr wrap="square" lIns="0" tIns="0" rIns="0" bIns="0" rtlCol="0" anchor="ctr"/>
           <a:lstStyle/>
           <a:p>
-            <a:pPr indent="0" marL="0">
+            <a:pPr marL="0" indent="0">
               <a:buNone/>
             </a:pPr>
             <a:r>
@@ -5436,7 +5352,7 @@
           <a:bodyPr wrap="square" lIns="0" tIns="0" rIns="0" bIns="0" rtlCol="0" anchor="ctr"/>
           <a:lstStyle/>
           <a:p>
-            <a:pPr indent="0" marL="0">
+            <a:pPr marL="0" indent="0">
               <a:buNone/>
             </a:pPr>
             <a:r>
@@ -5477,6 +5393,13 @@
             <a:prstDash val="solid"/>
           </a:ln>
         </p:spPr>
+        <p:txBody>
+          <a:bodyPr/>
+          <a:lstStyle/>
+          <a:p>
+            <a:endParaRPr lang="en-CR"/>
+          </a:p>
+        </p:txBody>
       </p:sp>
       <p:sp>
         <p:nvSpPr>
@@ -5499,7 +5422,7 @@
           <a:bodyPr wrap="square" lIns="0" tIns="0" rIns="0" bIns="0" rtlCol="0" anchor="ctr"/>
           <a:lstStyle/>
           <a:p>
-            <a:pPr indent="0" marL="0">
+            <a:pPr marL="0" indent="0">
               <a:buNone/>
             </a:pPr>
             <a:r>
@@ -5535,7 +5458,7 @@
           <a:bodyPr wrap="square" lIns="0" tIns="0" rIns="0" bIns="0" rtlCol="0" anchor="t"/>
           <a:lstStyle/>
           <a:p>
-            <a:pPr indent="0" marL="0">
+            <a:pPr marL="0" indent="0">
               <a:buNone/>
             </a:pPr>
             <a:r>
@@ -5570,7 +5493,7 @@
           </a:prstGeom>
           <a:extLst>
             <a:ext uri="{C572A759-6A51-4108-AA02-DFA0A04FC94B}">
-              <ma14:wrappingTextBoxFlag xmlns:ma14="http://schemas.microsoft.com/office/mac/drawingml/2011/main" val="0"/>
+              <ma14:wrappingTextBoxFlag xmlns:ma14="http://schemas.microsoft.com/office/mac/drawingml/2011/main" xmlns="" val="0"/>
             </a:ext>
           </a:extLst>
         </p:spPr>
@@ -5588,7 +5511,7 @@
           <a:p>
             <a:pPr algn="r"/>
             <a:fld id="{F7021451-1387-4CA6-816F-3879F97B5CBC}" type="slidenum">
-              <a:rPr b="0" lang="en-US"/>
+              <a:rPr lang="en-US" b="0"/>
               <a:t>13</a:t>
             </a:fld>
             <a:endParaRPr lang="en-US"/>
@@ -5623,9 +5546,11 @@
       <p:sp>
         <p:nvSpPr>
           <p:cNvPr id="2" name="Text 0"/>
-          <p:cNvSpPr/>
+          <p:cNvSpPr>
+            <a:spLocks noGrp="1"/>
+          </p:cNvSpPr>
           <p:nvPr>
-            <p:ph idx="100" type="title" hasCustomPrompt="1"/>
+            <p:ph type="title" idx="100" hasCustomPrompt="1"/>
           </p:nvPr>
         </p:nvSpPr>
         <p:spPr>
@@ -5643,7 +5568,7 @@
           <a:bodyPr wrap="square" lIns="0" tIns="0" rIns="0" bIns="0" rtlCol="0" anchor="ctr"/>
           <a:lstStyle/>
           <a:p>
-            <a:pPr indent="0" marL="0">
+            <a:pPr marL="0" indent="0">
               <a:buNone/>
             </a:pPr>
             <a:r>
@@ -5684,6 +5609,13 @@
             <a:prstDash val="solid"/>
           </a:ln>
         </p:spPr>
+        <p:txBody>
+          <a:bodyPr/>
+          <a:lstStyle/>
+          <a:p>
+            <a:endParaRPr lang="en-CR"/>
+          </a:p>
+        </p:txBody>
       </p:sp>
       <p:sp>
         <p:nvSpPr>
@@ -5711,6 +5643,13 @@
             <a:prstDash val="solid"/>
           </a:ln>
         </p:spPr>
+        <p:txBody>
+          <a:bodyPr/>
+          <a:lstStyle/>
+          <a:p>
+            <a:endParaRPr lang="en-CR"/>
+          </a:p>
+        </p:txBody>
       </p:sp>
       <p:sp>
         <p:nvSpPr>
@@ -5736,17 +5675,24 @@
             <a:prstDash val="solid"/>
           </a:ln>
         </p:spPr>
+        <p:txBody>
+          <a:bodyPr/>
+          <a:lstStyle/>
+          <a:p>
+            <a:endParaRPr lang="en-CR"/>
+          </a:p>
+        </p:txBody>
       </p:sp>
       <p:pic>
         <p:nvPicPr>
-          <p:cNvPr id="6" name="icon-FaCheck" descr="preencoded.png">    </p:cNvPr>
+          <p:cNvPr id="6" name="icon-FaCheck" descr="preencoded.png"/>
           <p:cNvPicPr>
             <a:picLocks noChangeAspect="1"/>
           </p:cNvPicPr>
           <p:nvPr/>
         </p:nvPicPr>
         <p:blipFill>
-          <a:blip r:embed="rId1"/>
+          <a:blip r:embed="rId3"/>
           <a:stretch>
             <a:fillRect/>
           </a:stretch>
@@ -5785,17 +5731,24 @@
             <a:prstDash val="solid"/>
           </a:ln>
         </p:spPr>
+        <p:txBody>
+          <a:bodyPr/>
+          <a:lstStyle/>
+          <a:p>
+            <a:endParaRPr lang="en-CR"/>
+          </a:p>
+        </p:txBody>
       </p:sp>
       <p:pic>
         <p:nvPicPr>
-          <p:cNvPr id="8" name="icon-FaTimes" descr="preencoded.png">    </p:cNvPr>
+          <p:cNvPr id="8" name="icon-FaTimes" descr="preencoded.png"/>
           <p:cNvPicPr>
             <a:picLocks noChangeAspect="1"/>
           </p:cNvPicPr>
           <p:nvPr/>
         </p:nvPicPr>
         <p:blipFill>
-          <a:blip r:embed="rId2"/>
+          <a:blip r:embed="rId4"/>
           <a:stretch>
             <a:fillRect/>
           </a:stretch>
@@ -5831,7 +5784,7 @@
           <a:bodyPr wrap="square" lIns="0" tIns="0" rIns="0" bIns="0" rtlCol="0" anchor="ctr"/>
           <a:lstStyle/>
           <a:p>
-            <a:pPr indent="0" marL="0">
+            <a:pPr marL="0" indent="0">
               <a:buNone/>
             </a:pPr>
             <a:r>
@@ -5867,7 +5820,7 @@
           <a:bodyPr wrap="square" lIns="0" tIns="0" rIns="0" bIns="0" rtlCol="0" anchor="ctr"/>
           <a:lstStyle/>
           <a:p>
-            <a:pPr indent="0" marL="0">
+            <a:pPr marL="0" indent="0">
               <a:buNone/>
             </a:pPr>
             <a:r>
@@ -6090,7 +6043,7 @@
           </a:prstGeom>
           <a:extLst>
             <a:ext uri="{C572A759-6A51-4108-AA02-DFA0A04FC94B}">
-              <ma14:wrappingTextBoxFlag xmlns:ma14="http://schemas.microsoft.com/office/mac/drawingml/2011/main" val="0"/>
+              <ma14:wrappingTextBoxFlag xmlns:ma14="http://schemas.microsoft.com/office/mac/drawingml/2011/main" xmlns="" val="0"/>
             </a:ext>
           </a:extLst>
         </p:spPr>
@@ -6108,7 +6061,7 @@
           <a:p>
             <a:pPr algn="r"/>
             <a:fld id="{F7021451-1387-4CA6-816F-3879F97B5CBC}" type="slidenum">
-              <a:rPr b="0" lang="en-US"/>
+              <a:rPr lang="en-US" b="0"/>
               <a:t>14</a:t>
             </a:fld>
             <a:endParaRPr lang="en-US"/>
@@ -6143,9 +6096,11 @@
       <p:sp>
         <p:nvSpPr>
           <p:cNvPr id="2" name="Text 0"/>
-          <p:cNvSpPr/>
+          <p:cNvSpPr>
+            <a:spLocks noGrp="1"/>
+          </p:cNvSpPr>
           <p:nvPr>
-            <p:ph idx="100" type="title" hasCustomPrompt="1"/>
+            <p:ph type="title" idx="100" hasCustomPrompt="1"/>
           </p:nvPr>
         </p:nvSpPr>
         <p:spPr>
@@ -6163,7 +6118,7 @@
           <a:bodyPr wrap="square" lIns="0" tIns="0" rIns="0" bIns="0" rtlCol="0" anchor="ctr"/>
           <a:lstStyle/>
           <a:p>
-            <a:pPr indent="0" marL="0">
+            <a:pPr marL="0" indent="0">
               <a:buNone/>
             </a:pPr>
             <a:r>
@@ -6204,13 +6159,20 @@
             <a:prstDash val="solid"/>
           </a:ln>
           <a:effectLst>
-            <a:outerShdw sx="100000" sy="100000" kx="0" ky="0" algn="bl" rotWithShape="0" blurRad="101600" dist="25400" dir="5400000">
+            <a:outerShdw blurRad="101600" dist="25400" dir="5400000" algn="bl" rotWithShape="0">
               <a:srgbClr val="000000">
                 <a:alpha val="18000"/>
               </a:srgbClr>
             </a:outerShdw>
           </a:effectLst>
         </p:spPr>
+        <p:txBody>
+          <a:bodyPr/>
+          <a:lstStyle/>
+          <a:p>
+            <a:endParaRPr lang="en-CR"/>
+          </a:p>
+        </p:txBody>
       </p:sp>
       <p:sp>
         <p:nvSpPr>
@@ -6233,7 +6195,7 @@
           <a:bodyPr wrap="square" lIns="0" tIns="0" rIns="0" bIns="0" rtlCol="0" anchor="ctr"/>
           <a:lstStyle/>
           <a:p>
-            <a:pPr indent="0" marL="0">
+            <a:pPr marL="0" indent="0">
               <a:buNone/>
             </a:pPr>
             <a:r>
@@ -6272,7 +6234,7 @@
           <a:bodyPr wrap="square" lIns="0" tIns="0" rIns="0" bIns="0" rtlCol="0" anchor="t"/>
           <a:lstStyle/>
           <a:p>
-            <a:pPr indent="0" marL="0">
+            <a:pPr marL="0" indent="0">
               <a:spcAft>
                 <a:spcPts val="200"/>
               </a:spcAft>
@@ -6292,7 +6254,7 @@
             <a:endParaRPr lang="en-US" sz="1200" dirty="0"/>
           </a:p>
           <a:p>
-            <a:pPr indent="0" marL="0">
+            <a:pPr marL="0" indent="0">
               <a:spcAft>
                 <a:spcPts val="200"/>
               </a:spcAft>
@@ -6312,7 +6274,7 @@
             <a:endParaRPr lang="en-US" sz="1200" dirty="0"/>
           </a:p>
           <a:p>
-            <a:pPr indent="0" marL="0">
+            <a:pPr marL="0" indent="0">
               <a:spcAft>
                 <a:spcPts val="200"/>
               </a:spcAft>
@@ -6332,7 +6294,7 @@
             <a:endParaRPr lang="en-US" sz="1200" dirty="0"/>
           </a:p>
           <a:p>
-            <a:pPr indent="0" marL="0">
+            <a:pPr marL="0" indent="0">
               <a:spcAft>
                 <a:spcPts val="200"/>
               </a:spcAft>
@@ -6352,7 +6314,7 @@
             <a:endParaRPr lang="en-US" sz="1200" dirty="0"/>
           </a:p>
           <a:p>
-            <a:pPr indent="0" marL="0">
+            <a:pPr marL="0" indent="0">
               <a:spcAft>
                 <a:spcPts val="200"/>
               </a:spcAft>
@@ -6372,7 +6334,7 @@
             <a:endParaRPr lang="en-US" sz="1200" dirty="0"/>
           </a:p>
           <a:p>
-            <a:pPr indent="0" marL="0">
+            <a:pPr marL="0" indent="0">
               <a:spcAft>
                 <a:spcPts val="200"/>
               </a:spcAft>
@@ -6392,7 +6354,7 @@
             <a:endParaRPr lang="en-US" sz="1200" dirty="0"/>
           </a:p>
           <a:p>
-            <a:pPr indent="0" marL="0">
+            <a:pPr marL="0" indent="0">
               <a:spcAft>
                 <a:spcPts val="200"/>
               </a:spcAft>
@@ -6412,7 +6374,7 @@
             <a:endParaRPr lang="en-US" sz="1200" dirty="0"/>
           </a:p>
           <a:p>
-            <a:pPr indent="0" marL="0">
+            <a:pPr marL="0" indent="0">
               <a:spcAft>
                 <a:spcPts val="200"/>
               </a:spcAft>
@@ -6432,7 +6394,7 @@
             <a:endParaRPr lang="en-US" sz="1200" dirty="0"/>
           </a:p>
           <a:p>
-            <a:pPr indent="0" marL="0">
+            <a:pPr marL="0" indent="0">
               <a:spcAft>
                 <a:spcPts val="200"/>
               </a:spcAft>
@@ -6452,7 +6414,7 @@
             <a:endParaRPr lang="en-US" sz="1200" dirty="0"/>
           </a:p>
           <a:p>
-            <a:pPr indent="0" marL="0">
+            <a:pPr marL="0" indent="0">
               <a:spcAft>
                 <a:spcPts val="200"/>
               </a:spcAft>
@@ -6497,17 +6459,24 @@
             <a:prstDash val="solid"/>
           </a:ln>
         </p:spPr>
+        <p:txBody>
+          <a:bodyPr/>
+          <a:lstStyle/>
+          <a:p>
+            <a:endParaRPr lang="en-CR"/>
+          </a:p>
+        </p:txBody>
       </p:sp>
       <p:pic>
         <p:nvPicPr>
-          <p:cNvPr id="7" name="icon-FaRoute" descr="preencoded.png">    </p:cNvPr>
+          <p:cNvPr id="7" name="icon-FaRoute" descr="preencoded.png"/>
           <p:cNvPicPr>
             <a:picLocks noChangeAspect="1"/>
           </p:cNvPicPr>
           <p:nvPr/>
         </p:nvPicPr>
         <p:blipFill>
-          <a:blip r:embed="rId1"/>
+          <a:blip r:embed="rId3"/>
           <a:stretch>
             <a:fillRect/>
           </a:stretch>
@@ -6543,7 +6512,7 @@
           <a:bodyPr wrap="square" lIns="0" tIns="0" rIns="0" bIns="0" rtlCol="0" anchor="ctr"/>
           <a:lstStyle/>
           <a:p>
-            <a:pPr indent="0" marL="0">
+            <a:pPr marL="0" indent="0">
               <a:buNone/>
             </a:pPr>
             <a:r>
@@ -6579,7 +6548,7 @@
           <a:bodyPr wrap="square" lIns="0" tIns="0" rIns="0" bIns="0" rtlCol="0" anchor="ctr"/>
           <a:lstStyle/>
           <a:p>
-            <a:pPr indent="0" marL="0">
+            <a:pPr marL="0" indent="0">
               <a:buNone/>
             </a:pPr>
             <a:r>
@@ -6618,17 +6587,24 @@
             <a:prstDash val="solid"/>
           </a:ln>
         </p:spPr>
+        <p:txBody>
+          <a:bodyPr/>
+          <a:lstStyle/>
+          <a:p>
+            <a:endParaRPr lang="en-CR"/>
+          </a:p>
+        </p:txBody>
       </p:sp>
       <p:pic>
         <p:nvPicPr>
-          <p:cNvPr id="11" name="icon-FaBolt" descr="preencoded.png">    </p:cNvPr>
+          <p:cNvPr id="11" name="icon-FaBolt" descr="preencoded.png"/>
           <p:cNvPicPr>
             <a:picLocks noChangeAspect="1"/>
           </p:cNvPicPr>
           <p:nvPr/>
         </p:nvPicPr>
         <p:blipFill>
-          <a:blip r:embed="rId2"/>
+          <a:blip r:embed="rId4"/>
           <a:stretch>
             <a:fillRect/>
           </a:stretch>
@@ -6664,7 +6640,7 @@
           <a:bodyPr wrap="square" lIns="0" tIns="0" rIns="0" bIns="0" rtlCol="0" anchor="ctr"/>
           <a:lstStyle/>
           <a:p>
-            <a:pPr indent="0" marL="0">
+            <a:pPr marL="0" indent="0">
               <a:buNone/>
             </a:pPr>
             <a:r>
@@ -6700,7 +6676,7 @@
           <a:bodyPr wrap="square" lIns="0" tIns="0" rIns="0" bIns="0" rtlCol="0" anchor="ctr"/>
           <a:lstStyle/>
           <a:p>
-            <a:pPr indent="0" marL="0">
+            <a:pPr marL="0" indent="0">
               <a:buNone/>
             </a:pPr>
             <a:r>
@@ -6739,17 +6715,24 @@
             <a:prstDash val="solid"/>
           </a:ln>
         </p:spPr>
+        <p:txBody>
+          <a:bodyPr/>
+          <a:lstStyle/>
+          <a:p>
+            <a:endParaRPr lang="en-CR"/>
+          </a:p>
+        </p:txBody>
       </p:sp>
       <p:pic>
         <p:nvPicPr>
-          <p:cNvPr id="15" name="icon-FaLifeRing" descr="preencoded.png">    </p:cNvPr>
+          <p:cNvPr id="15" name="icon-FaLifeRing" descr="preencoded.png"/>
           <p:cNvPicPr>
             <a:picLocks noChangeAspect="1"/>
           </p:cNvPicPr>
           <p:nvPr/>
         </p:nvPicPr>
         <p:blipFill>
-          <a:blip r:embed="rId3"/>
+          <a:blip r:embed="rId5"/>
           <a:stretch>
             <a:fillRect/>
           </a:stretch>
@@ -6785,7 +6768,7 @@
           <a:bodyPr wrap="square" lIns="0" tIns="0" rIns="0" bIns="0" rtlCol="0" anchor="ctr"/>
           <a:lstStyle/>
           <a:p>
-            <a:pPr indent="0" marL="0">
+            <a:pPr marL="0" indent="0">
               <a:buNone/>
             </a:pPr>
             <a:r>
@@ -6821,7 +6804,7 @@
           <a:bodyPr wrap="square" lIns="0" tIns="0" rIns="0" bIns="0" rtlCol="0" anchor="ctr"/>
           <a:lstStyle/>
           <a:p>
-            <a:pPr indent="0" marL="0">
+            <a:pPr marL="0" indent="0">
               <a:buNone/>
             </a:pPr>
             <a:r>
@@ -6857,7 +6840,7 @@
           <a:bodyPr wrap="square" lIns="0" tIns="0" rIns="0" bIns="0" rtlCol="0" anchor="ctr"/>
           <a:lstStyle/>
           <a:p>
-            <a:pPr indent="0" marL="0">
+            <a:pPr marL="0" indent="0">
               <a:buNone/>
             </a:pPr>
             <a:r>
@@ -6892,7 +6875,7 @@
           </a:prstGeom>
           <a:extLst>
             <a:ext uri="{C572A759-6A51-4108-AA02-DFA0A04FC94B}">
-              <ma14:wrappingTextBoxFlag xmlns:ma14="http://schemas.microsoft.com/office/mac/drawingml/2011/main" val="0"/>
+              <ma14:wrappingTextBoxFlag xmlns:ma14="http://schemas.microsoft.com/office/mac/drawingml/2011/main" xmlns="" val="0"/>
             </a:ext>
           </a:extLst>
         </p:spPr>
@@ -6910,7 +6893,7 @@
           <a:p>
             <a:pPr algn="r"/>
             <a:fld id="{F7021451-1387-4CA6-816F-3879F97B5CBC}" type="slidenum">
-              <a:rPr b="0" lang="en-US"/>
+              <a:rPr lang="en-US" b="0"/>
               <a:t>15</a:t>
             </a:fld>
             <a:endParaRPr lang="en-US"/>
@@ -6945,9 +6928,11 @@
       <p:sp>
         <p:nvSpPr>
           <p:cNvPr id="2" name="Text 0"/>
-          <p:cNvSpPr/>
+          <p:cNvSpPr>
+            <a:spLocks noGrp="1"/>
+          </p:cNvSpPr>
           <p:nvPr>
-            <p:ph idx="100" type="title" hasCustomPrompt="1"/>
+            <p:ph type="title" idx="100" hasCustomPrompt="1"/>
           </p:nvPr>
         </p:nvSpPr>
         <p:spPr>
@@ -6965,7 +6950,7 @@
           <a:bodyPr wrap="square" lIns="0" tIns="0" rIns="0" bIns="0" rtlCol="0" anchor="b"/>
           <a:lstStyle/>
           <a:p>
-            <a:pPr algn="l" indent="0" marL="0">
+            <a:pPr marL="0" indent="0" algn="l">
               <a:buNone/>
             </a:pPr>
             <a:r>
@@ -6983,9 +6968,11 @@
       <p:sp>
         <p:nvSpPr>
           <p:cNvPr id="3" name="Text 0"/>
-          <p:cNvSpPr/>
+          <p:cNvSpPr>
+            <a:spLocks noGrp="1"/>
+          </p:cNvSpPr>
           <p:nvPr>
-            <p:ph idx="101" type="body" hasCustomPrompt="1"/>
+            <p:ph type="body" idx="101" hasCustomPrompt="1"/>
           </p:nvPr>
         </p:nvSpPr>
         <p:spPr>
@@ -7003,7 +6990,7 @@
           <a:bodyPr wrap="square" lIns="0" tIns="0" rIns="0" bIns="0" rtlCol="0" anchor="t"/>
           <a:lstStyle/>
           <a:p>
-            <a:pPr algn="l" indent="0" marL="0">
+            <a:pPr marL="0" indent="0" algn="l">
               <a:buNone/>
             </a:pPr>
             <a:r>
@@ -7042,17 +7029,24 @@
             <a:prstDash val="solid"/>
           </a:ln>
         </p:spPr>
+        <p:txBody>
+          <a:bodyPr/>
+          <a:lstStyle/>
+          <a:p>
+            <a:endParaRPr lang="en-CR"/>
+          </a:p>
+        </p:txBody>
       </p:sp>
       <p:pic>
         <p:nvPicPr>
-          <p:cNvPr id="5" name="icon-FaFileAlt" descr="preencoded.png">    </p:cNvPr>
+          <p:cNvPr id="5" name="icon-FaFileAlt" descr="preencoded.png"/>
           <p:cNvPicPr>
             <a:picLocks noChangeAspect="1"/>
           </p:cNvPicPr>
           <p:nvPr/>
         </p:nvPicPr>
         <p:blipFill>
-          <a:blip r:embed="rId1"/>
+          <a:blip r:embed="rId3"/>
           <a:stretch>
             <a:fillRect/>
           </a:stretch>
@@ -7088,7 +7082,7 @@
           <a:bodyPr wrap="square" lIns="0" tIns="0" rIns="0" bIns="0" rtlCol="0" anchor="ctr"/>
           <a:lstStyle/>
           <a:p>
-            <a:pPr indent="0" marL="0">
+            <a:pPr marL="0" indent="0">
               <a:buNone/>
             </a:pPr>
             <a:r>
@@ -7127,17 +7121,24 @@
             <a:prstDash val="solid"/>
           </a:ln>
         </p:spPr>
+        <p:txBody>
+          <a:bodyPr/>
+          <a:lstStyle/>
+          <a:p>
+            <a:endParaRPr lang="en-CR"/>
+          </a:p>
+        </p:txBody>
       </p:sp>
       <p:pic>
         <p:nvPicPr>
-          <p:cNvPr id="8" name="icon-FaQuestionCircle" descr="preencoded.png">    </p:cNvPr>
+          <p:cNvPr id="8" name="icon-FaQuestionCircle" descr="preencoded.png"/>
           <p:cNvPicPr>
             <a:picLocks noChangeAspect="1"/>
           </p:cNvPicPr>
           <p:nvPr/>
         </p:nvPicPr>
         <p:blipFill>
-          <a:blip r:embed="rId2"/>
+          <a:blip r:embed="rId4"/>
           <a:stretch>
             <a:fillRect/>
           </a:stretch>
@@ -7173,7 +7174,7 @@
           <a:bodyPr wrap="square" lIns="0" tIns="0" rIns="0" bIns="0" rtlCol="0" anchor="ctr"/>
           <a:lstStyle/>
           <a:p>
-            <a:pPr indent="0" marL="0">
+            <a:pPr marL="0" indent="0">
               <a:buNone/>
             </a:pPr>
             <a:r>
@@ -7212,17 +7213,24 @@
             <a:prstDash val="solid"/>
           </a:ln>
         </p:spPr>
+        <p:txBody>
+          <a:bodyPr/>
+          <a:lstStyle/>
+          <a:p>
+            <a:endParaRPr lang="en-CR"/>
+          </a:p>
+        </p:txBody>
       </p:sp>
       <p:pic>
         <p:nvPicPr>
-          <p:cNvPr id="11" name="icon-FaLink" descr="preencoded.png">    </p:cNvPr>
+          <p:cNvPr id="11" name="icon-FaLink" descr="preencoded.png"/>
           <p:cNvPicPr>
             <a:picLocks noChangeAspect="1"/>
           </p:cNvPicPr>
           <p:nvPr/>
         </p:nvPicPr>
         <p:blipFill>
-          <a:blip r:embed="rId3"/>
+          <a:blip r:embed="rId5"/>
           <a:stretch>
             <a:fillRect/>
           </a:stretch>
@@ -7258,7 +7266,7 @@
           <a:bodyPr wrap="square" lIns="0" tIns="0" rIns="0" bIns="0" rtlCol="0" anchor="ctr"/>
           <a:lstStyle/>
           <a:p>
-            <a:pPr indent="0" marL="0">
+            <a:pPr marL="0" indent="0">
               <a:buNone/>
             </a:pPr>
             <a:r>
@@ -7294,7 +7302,7 @@
           <a:bodyPr wrap="square" lIns="0" tIns="0" rIns="0" bIns="0" rtlCol="0" anchor="ctr"/>
           <a:lstStyle/>
           <a:p>
-            <a:pPr indent="0" marL="0">
+            <a:pPr marL="0" indent="0">
               <a:buNone/>
             </a:pPr>
             <a:r>
@@ -7312,6 +7320,36 @@
           </a:p>
         </p:txBody>
       </p:sp>
+      <p:pic>
+        <p:nvPicPr>
+          <p:cNvPr id="15" name="Picture 14">
+            <a:extLst>
+              <a:ext uri="{FF2B5EF4-FFF2-40B4-BE49-F238E27FC236}">
+                <a16:creationId xmlns:a16="http://schemas.microsoft.com/office/drawing/2014/main" id="{4FF11F78-E8A3-CE27-40A4-3223B4556B02}"/>
+              </a:ext>
+            </a:extLst>
+          </p:cNvPr>
+          <p:cNvPicPr>
+            <a:picLocks noChangeAspect="1"/>
+          </p:cNvPicPr>
+          <p:nvPr/>
+        </p:nvPicPr>
+        <p:blipFill>
+          <a:blip r:embed="rId6"/>
+          <a:stretch>
+            <a:fillRect/>
+          </a:stretch>
+        </p:blipFill>
+        <p:spPr>
+          <a:xfrm>
+            <a:off x="1512685" y="115122"/>
+            <a:ext cx="1894607" cy="1849227"/>
+          </a:xfrm>
+          <a:prstGeom prst="rect">
+            <a:avLst/>
+          </a:prstGeom>
+        </p:spPr>
+      </p:pic>
     </p:spTree>
   </p:cSld>
   <p:clrMapOvr>
@@ -7340,9 +7378,11 @@
       <p:sp>
         <p:nvSpPr>
           <p:cNvPr id="2" name="Text 0"/>
-          <p:cNvSpPr/>
+          <p:cNvSpPr>
+            <a:spLocks noGrp="1"/>
+          </p:cNvSpPr>
           <p:nvPr>
-            <p:ph idx="100" type="title" hasCustomPrompt="1"/>
+            <p:ph type="title" idx="100" hasCustomPrompt="1"/>
           </p:nvPr>
         </p:nvSpPr>
         <p:spPr>
@@ -7360,7 +7400,7 @@
           <a:bodyPr wrap="square" lIns="0" tIns="0" rIns="0" bIns="0" rtlCol="0" anchor="ctr"/>
           <a:lstStyle/>
           <a:p>
-            <a:pPr indent="0" marL="0">
+            <a:pPr marL="0" indent="0">
               <a:buNone/>
             </a:pPr>
             <a:r>
@@ -7377,14 +7417,14 @@
       </p:sp>
       <p:pic>
         <p:nvPicPr>
-          <p:cNvPr id="3" name="vibe-vs-spec" descr="img/vibe.png">    </p:cNvPr>
+          <p:cNvPr id="3" name="vibe-vs-spec" descr="img/vibe.png"/>
           <p:cNvPicPr>
             <a:picLocks noChangeAspect="1"/>
           </p:cNvPicPr>
           <p:nvPr/>
         </p:nvPicPr>
         <p:blipFill>
-          <a:blip r:embed="rId1"/>
+          <a:blip r:embed="rId3"/>
           <a:stretch>
             <a:fillRect/>
           </a:stretch>
@@ -7423,17 +7463,24 @@
             <a:prstDash val="solid"/>
           </a:ln>
         </p:spPr>
+        <p:txBody>
+          <a:bodyPr/>
+          <a:lstStyle/>
+          <a:p>
+            <a:endParaRPr lang="en-CR"/>
+          </a:p>
+        </p:txBody>
       </p:sp>
       <p:pic>
         <p:nvPicPr>
-          <p:cNvPr id="5" name="icon-FaWind" descr="preencoded.png">    </p:cNvPr>
+          <p:cNvPr id="5" name="icon-FaWind" descr="preencoded.png"/>
           <p:cNvPicPr>
             <a:picLocks noChangeAspect="1"/>
           </p:cNvPicPr>
           <p:nvPr/>
         </p:nvPicPr>
         <p:blipFill>
-          <a:blip r:embed="rId2"/>
+          <a:blip r:embed="rId4"/>
           <a:stretch>
             <a:fillRect/>
           </a:stretch>
@@ -7469,7 +7516,7 @@
           <a:bodyPr wrap="square" lIns="0" tIns="0" rIns="0" bIns="0" rtlCol="0" anchor="ctr"/>
           <a:lstStyle/>
           <a:p>
-            <a:pPr indent="0" marL="0">
+            <a:pPr marL="0" indent="0">
               <a:buNone/>
             </a:pPr>
             <a:r>
@@ -7505,7 +7552,7 @@
           <a:bodyPr wrap="square" lIns="0" tIns="0" rIns="0" bIns="0" rtlCol="0" anchor="ctr"/>
           <a:lstStyle/>
           <a:p>
-            <a:pPr indent="0" marL="0">
+            <a:pPr marL="0" indent="0">
               <a:buNone/>
             </a:pPr>
             <a:r>
@@ -7544,17 +7591,24 @@
             <a:prstDash val="solid"/>
           </a:ln>
         </p:spPr>
+        <p:txBody>
+          <a:bodyPr/>
+          <a:lstStyle/>
+          <a:p>
+            <a:endParaRPr lang="en-CR"/>
+          </a:p>
+        </p:txBody>
       </p:sp>
       <p:pic>
         <p:nvPicPr>
-          <p:cNvPr id="9" name="icon-FaDice" descr="preencoded.png">    </p:cNvPr>
+          <p:cNvPr id="9" name="icon-FaDice" descr="preencoded.png"/>
           <p:cNvPicPr>
             <a:picLocks noChangeAspect="1"/>
           </p:cNvPicPr>
           <p:nvPr/>
         </p:nvPicPr>
         <p:blipFill>
-          <a:blip r:embed="rId3"/>
+          <a:blip r:embed="rId5"/>
           <a:stretch>
             <a:fillRect/>
           </a:stretch>
@@ -7590,7 +7644,7 @@
           <a:bodyPr wrap="square" lIns="0" tIns="0" rIns="0" bIns="0" rtlCol="0" anchor="ctr"/>
           <a:lstStyle/>
           <a:p>
-            <a:pPr indent="0" marL="0">
+            <a:pPr marL="0" indent="0">
               <a:buNone/>
             </a:pPr>
             <a:r>
@@ -7626,7 +7680,7 @@
           <a:bodyPr wrap="square" lIns="0" tIns="0" rIns="0" bIns="0" rtlCol="0" anchor="ctr"/>
           <a:lstStyle/>
           <a:p>
-            <a:pPr indent="0" marL="0">
+            <a:pPr marL="0" indent="0">
               <a:buNone/>
             </a:pPr>
             <a:r>
@@ -7665,17 +7719,24 @@
             <a:prstDash val="solid"/>
           </a:ln>
         </p:spPr>
+        <p:txBody>
+          <a:bodyPr/>
+          <a:lstStyle/>
+          <a:p>
+            <a:endParaRPr lang="en-CR"/>
+          </a:p>
+        </p:txBody>
       </p:sp>
       <p:pic>
         <p:nvPicPr>
-          <p:cNvPr id="13" name="icon-FaEyeSlash" descr="preencoded.png">    </p:cNvPr>
+          <p:cNvPr id="13" name="icon-FaEyeSlash" descr="preencoded.png"/>
           <p:cNvPicPr>
             <a:picLocks noChangeAspect="1"/>
           </p:cNvPicPr>
           <p:nvPr/>
         </p:nvPicPr>
         <p:blipFill>
-          <a:blip r:embed="rId4"/>
+          <a:blip r:embed="rId6"/>
           <a:stretch>
             <a:fillRect/>
           </a:stretch>
@@ -7711,7 +7772,7 @@
           <a:bodyPr wrap="square" lIns="0" tIns="0" rIns="0" bIns="0" rtlCol="0" anchor="ctr"/>
           <a:lstStyle/>
           <a:p>
-            <a:pPr indent="0" marL="0">
+            <a:pPr marL="0" indent="0">
               <a:buNone/>
             </a:pPr>
             <a:r>
@@ -7747,7 +7808,7 @@
           <a:bodyPr wrap="square" lIns="0" tIns="0" rIns="0" bIns="0" rtlCol="0" anchor="ctr"/>
           <a:lstStyle/>
           <a:p>
-            <a:pPr indent="0" marL="0">
+            <a:pPr marL="0" indent="0">
               <a:buNone/>
             </a:pPr>
             <a:r>
@@ -7782,7 +7843,7 @@
           </a:prstGeom>
           <a:extLst>
             <a:ext uri="{C572A759-6A51-4108-AA02-DFA0A04FC94B}">
-              <ma14:wrappingTextBoxFlag xmlns:ma14="http://schemas.microsoft.com/office/mac/drawingml/2011/main" val="0"/>
+              <ma14:wrappingTextBoxFlag xmlns:ma14="http://schemas.microsoft.com/office/mac/drawingml/2011/main" xmlns="" val="0"/>
             </a:ext>
           </a:extLst>
         </p:spPr>
@@ -7800,7 +7861,7 @@
           <a:p>
             <a:pPr algn="r"/>
             <a:fld id="{F7021451-1387-4CA6-816F-3879F97B5CBC}" type="slidenum">
-              <a:rPr b="0" lang="en-US"/>
+              <a:rPr lang="en-US" b="0"/>
               <a:t>2</a:t>
             </a:fld>
             <a:endParaRPr lang="en-US"/>
@@ -7835,9 +7896,11 @@
       <p:sp>
         <p:nvSpPr>
           <p:cNvPr id="2" name="Text 0"/>
-          <p:cNvSpPr/>
+          <p:cNvSpPr>
+            <a:spLocks noGrp="1"/>
+          </p:cNvSpPr>
           <p:nvPr>
-            <p:ph idx="100" type="title" hasCustomPrompt="1"/>
+            <p:ph type="title" idx="100" hasCustomPrompt="1"/>
           </p:nvPr>
         </p:nvSpPr>
         <p:spPr>
@@ -7855,7 +7918,7 @@
           <a:bodyPr wrap="square" lIns="0" tIns="0" rIns="0" bIns="0" rtlCol="0" anchor="ctr"/>
           <a:lstStyle/>
           <a:p>
-            <a:pPr indent="0" marL="0">
+            <a:pPr marL="0" indent="0">
               <a:buNone/>
             </a:pPr>
             <a:r>
@@ -7896,6 +7959,13 @@
             <a:prstDash val="solid"/>
           </a:ln>
         </p:spPr>
+        <p:txBody>
+          <a:bodyPr/>
+          <a:lstStyle/>
+          <a:p>
+            <a:endParaRPr lang="en-CR"/>
+          </a:p>
+        </p:txBody>
       </p:sp>
       <p:sp>
         <p:nvSpPr>
@@ -7923,6 +7993,13 @@
             <a:prstDash val="solid"/>
           </a:ln>
         </p:spPr>
+        <p:txBody>
+          <a:bodyPr/>
+          <a:lstStyle/>
+          <a:p>
+            <a:endParaRPr lang="en-CR"/>
+          </a:p>
+        </p:txBody>
       </p:sp>
       <p:sp>
         <p:nvSpPr>
@@ -7948,17 +8025,24 @@
             <a:prstDash val="solid"/>
           </a:ln>
         </p:spPr>
+        <p:txBody>
+          <a:bodyPr/>
+          <a:lstStyle/>
+          <a:p>
+            <a:endParaRPr lang="en-CR"/>
+          </a:p>
+        </p:txBody>
       </p:sp>
       <p:pic>
         <p:nvPicPr>
-          <p:cNvPr id="6" name="icon-FaCode" descr="preencoded.png">    </p:cNvPr>
+          <p:cNvPr id="6" name="icon-FaCode" descr="preencoded.png"/>
           <p:cNvPicPr>
             <a:picLocks noChangeAspect="1"/>
           </p:cNvPicPr>
           <p:nvPr/>
         </p:nvPicPr>
         <p:blipFill>
-          <a:blip r:embed="rId1"/>
+          <a:blip r:embed="rId3"/>
           <a:stretch>
             <a:fillRect/>
           </a:stretch>
@@ -7997,17 +8081,24 @@
             <a:prstDash val="solid"/>
           </a:ln>
         </p:spPr>
+        <p:txBody>
+          <a:bodyPr/>
+          <a:lstStyle/>
+          <a:p>
+            <a:endParaRPr lang="en-CR"/>
+          </a:p>
+        </p:txBody>
       </p:sp>
       <p:pic>
         <p:nvPicPr>
-          <p:cNvPr id="8" name="icon-FaFileSignature" descr="preencoded.png">    </p:cNvPr>
+          <p:cNvPr id="8" name="icon-FaFileSignature" descr="preencoded.png"/>
           <p:cNvPicPr>
             <a:picLocks noChangeAspect="1"/>
           </p:cNvPicPr>
           <p:nvPr/>
         </p:nvPicPr>
         <p:blipFill>
-          <a:blip r:embed="rId2"/>
+          <a:blip r:embed="rId4"/>
           <a:stretch>
             <a:fillRect/>
           </a:stretch>
@@ -8043,7 +8134,7 @@
           <a:bodyPr wrap="square" lIns="0" tIns="0" rIns="0" bIns="0" rtlCol="0" anchor="ctr"/>
           <a:lstStyle/>
           <a:p>
-            <a:pPr indent="0" marL="0">
+            <a:pPr marL="0" indent="0">
               <a:buNone/>
             </a:pPr>
             <a:r>
@@ -8079,7 +8170,7 @@
           <a:bodyPr wrap="square" lIns="0" tIns="0" rIns="0" bIns="0" rtlCol="0" anchor="ctr"/>
           <a:lstStyle/>
           <a:p>
-            <a:pPr indent="0" marL="0">
+            <a:pPr marL="0" indent="0">
               <a:buNone/>
             </a:pPr>
             <a:r>
@@ -8306,17 +8397,24 @@
             <a:prstDash val="solid"/>
           </a:ln>
         </p:spPr>
+        <p:txBody>
+          <a:bodyPr/>
+          <a:lstStyle/>
+          <a:p>
+            <a:endParaRPr lang="en-CR"/>
+          </a:p>
+        </p:txBody>
       </p:sp>
       <p:pic>
         <p:nvPicPr>
-          <p:cNvPr id="14" name="icon-FaArrowRight" descr="preencoded.png">    </p:cNvPr>
+          <p:cNvPr id="14" name="icon-FaArrowRight" descr="preencoded.png"/>
           <p:cNvPicPr>
             <a:picLocks noChangeAspect="1"/>
           </p:cNvPicPr>
           <p:nvPr/>
         </p:nvPicPr>
         <p:blipFill>
-          <a:blip r:embed="rId3"/>
+          <a:blip r:embed="rId5"/>
           <a:stretch>
             <a:fillRect/>
           </a:stretch>
@@ -8351,7 +8449,7 @@
           </a:prstGeom>
           <a:extLst>
             <a:ext uri="{C572A759-6A51-4108-AA02-DFA0A04FC94B}">
-              <ma14:wrappingTextBoxFlag xmlns:ma14="http://schemas.microsoft.com/office/mac/drawingml/2011/main" val="0"/>
+              <ma14:wrappingTextBoxFlag xmlns:ma14="http://schemas.microsoft.com/office/mac/drawingml/2011/main" xmlns="" val="0"/>
             </a:ext>
           </a:extLst>
         </p:spPr>
@@ -8369,7 +8467,7 @@
           <a:p>
             <a:pPr algn="r"/>
             <a:fld id="{F7021451-1387-4CA6-816F-3879F97B5CBC}" type="slidenum">
-              <a:rPr b="0" lang="en-US"/>
+              <a:rPr lang="en-US" b="0"/>
               <a:t>3</a:t>
             </a:fld>
             <a:endParaRPr lang="en-US"/>
@@ -8404,9 +8502,11 @@
       <p:sp>
         <p:nvSpPr>
           <p:cNvPr id="2" name="Text 0"/>
-          <p:cNvSpPr/>
+          <p:cNvSpPr>
+            <a:spLocks noGrp="1"/>
+          </p:cNvSpPr>
           <p:nvPr>
-            <p:ph idx="100" type="title" hasCustomPrompt="1"/>
+            <p:ph type="title" idx="100" hasCustomPrompt="1"/>
           </p:nvPr>
         </p:nvSpPr>
         <p:spPr>
@@ -8424,7 +8524,7 @@
           <a:bodyPr wrap="square" lIns="0" tIns="0" rIns="0" bIns="0" rtlCol="0" anchor="ctr"/>
           <a:lstStyle/>
           <a:p>
-            <a:pPr indent="0" marL="0">
+            <a:pPr marL="0" indent="0">
               <a:buNone/>
             </a:pPr>
             <a:r>
@@ -8465,6 +8565,13 @@
             <a:prstDash val="solid"/>
           </a:ln>
         </p:spPr>
+        <p:txBody>
+          <a:bodyPr/>
+          <a:lstStyle/>
+          <a:p>
+            <a:endParaRPr lang="en-CR"/>
+          </a:p>
+        </p:txBody>
       </p:sp>
       <p:sp>
         <p:nvSpPr>
@@ -8490,17 +8597,24 @@
             <a:prstDash val="solid"/>
           </a:ln>
         </p:spPr>
+        <p:txBody>
+          <a:bodyPr/>
+          <a:lstStyle/>
+          <a:p>
+            <a:endParaRPr lang="en-CR"/>
+          </a:p>
+        </p:txBody>
       </p:sp>
       <p:pic>
         <p:nvPicPr>
-          <p:cNvPr id="5" name="icon-FaPencilRuler" descr="preencoded.png">    </p:cNvPr>
+          <p:cNvPr id="5" name="icon-FaPencilRuler" descr="preencoded.png"/>
           <p:cNvPicPr>
             <a:picLocks noChangeAspect="1"/>
           </p:cNvPicPr>
           <p:nvPr/>
         </p:nvPicPr>
         <p:blipFill>
-          <a:blip r:embed="rId1"/>
+          <a:blip r:embed="rId3"/>
           <a:stretch>
             <a:fillRect/>
           </a:stretch>
@@ -8536,11 +8650,11 @@
           <a:bodyPr wrap="square" lIns="0" tIns="0" rIns="0" bIns="0" rtlCol="0" anchor="ctr"/>
           <a:lstStyle/>
           <a:p>
-            <a:pPr indent="0" marL="0">
-              <a:buNone/>
-            </a:pPr>
-            <a:r>
-              <a:rPr lang="en-US" sz="1100" b="1" spc="200" kern="0" dirty="0">
+            <a:pPr marL="0" indent="0">
+              <a:buNone/>
+            </a:pPr>
+            <a:r>
+              <a:rPr lang="en-US" sz="1100" b="1" kern="0" spc="200" dirty="0">
                 <a:solidFill>
                   <a:schemeClr val="accent6"/>
                 </a:solidFill>
@@ -8572,7 +8686,7 @@
           <a:bodyPr wrap="square" lIns="0" tIns="0" rIns="0" bIns="0" rtlCol="0" anchor="ctr"/>
           <a:lstStyle/>
           <a:p>
-            <a:pPr indent="0" marL="0">
+            <a:pPr marL="0" indent="0">
               <a:buNone/>
             </a:pPr>
             <a:r>
@@ -8608,7 +8722,7 @@
           <a:bodyPr wrap="square" lIns="0" tIns="0" rIns="0" bIns="0" rtlCol="0" anchor="t"/>
           <a:lstStyle/>
           <a:p>
-            <a:pPr indent="0" marL="0">
+            <a:pPr marL="0" indent="0">
               <a:buNone/>
             </a:pPr>
             <a:r>
@@ -8644,7 +8758,7 @@
           <a:bodyPr wrap="square" lIns="0" tIns="0" rIns="0" bIns="0" rtlCol="0" anchor="t"/>
           <a:lstStyle/>
           <a:p>
-            <a:pPr indent="0" marL="0">
+            <a:pPr marL="0" indent="0">
               <a:buNone/>
             </a:pPr>
             <a:r>
@@ -8685,6 +8799,13 @@
             <a:prstDash val="solid"/>
           </a:ln>
         </p:spPr>
+        <p:txBody>
+          <a:bodyPr/>
+          <a:lstStyle/>
+          <a:p>
+            <a:endParaRPr lang="en-CR"/>
+          </a:p>
+        </p:txBody>
       </p:sp>
       <p:sp>
         <p:nvSpPr>
@@ -8710,17 +8831,24 @@
             <a:prstDash val="solid"/>
           </a:ln>
         </p:spPr>
+        <p:txBody>
+          <a:bodyPr/>
+          <a:lstStyle/>
+          <a:p>
+            <a:endParaRPr lang="en-CR"/>
+          </a:p>
+        </p:txBody>
       </p:sp>
       <p:pic>
         <p:nvPicPr>
-          <p:cNvPr id="12" name="icon-FaAnchor" descr="preencoded.png">    </p:cNvPr>
+          <p:cNvPr id="12" name="icon-FaAnchor" descr="preencoded.png"/>
           <p:cNvPicPr>
             <a:picLocks noChangeAspect="1"/>
           </p:cNvPicPr>
           <p:nvPr/>
         </p:nvPicPr>
         <p:blipFill>
-          <a:blip r:embed="rId2"/>
+          <a:blip r:embed="rId4"/>
           <a:stretch>
             <a:fillRect/>
           </a:stretch>
@@ -8756,11 +8884,11 @@
           <a:bodyPr wrap="square" lIns="0" tIns="0" rIns="0" bIns="0" rtlCol="0" anchor="ctr"/>
           <a:lstStyle/>
           <a:p>
-            <a:pPr indent="0" marL="0">
-              <a:buNone/>
-            </a:pPr>
-            <a:r>
-              <a:rPr lang="en-US" sz="1100" b="1" spc="200" kern="0" dirty="0">
+            <a:pPr marL="0" indent="0">
+              <a:buNone/>
+            </a:pPr>
+            <a:r>
+              <a:rPr lang="en-US" sz="1100" b="1" kern="0" spc="200" dirty="0">
                 <a:solidFill>
                   <a:schemeClr val="accent6"/>
                 </a:solidFill>
@@ -8792,7 +8920,7 @@
           <a:bodyPr wrap="square" lIns="0" tIns="0" rIns="0" bIns="0" rtlCol="0" anchor="ctr"/>
           <a:lstStyle/>
           <a:p>
-            <a:pPr indent="0" marL="0">
+            <a:pPr marL="0" indent="0">
               <a:buNone/>
             </a:pPr>
             <a:r>
@@ -8828,7 +8956,7 @@
           <a:bodyPr wrap="square" lIns="0" tIns="0" rIns="0" bIns="0" rtlCol="0" anchor="t"/>
           <a:lstStyle/>
           <a:p>
-            <a:pPr indent="0" marL="0">
+            <a:pPr marL="0" indent="0">
               <a:buNone/>
             </a:pPr>
             <a:r>
@@ -8864,7 +8992,7 @@
           <a:bodyPr wrap="square" lIns="0" tIns="0" rIns="0" bIns="0" rtlCol="0" anchor="t"/>
           <a:lstStyle/>
           <a:p>
-            <a:pPr indent="0" marL="0">
+            <a:pPr marL="0" indent="0">
               <a:buNone/>
             </a:pPr>
             <a:r>
@@ -8905,6 +9033,13 @@
             <a:prstDash val="solid"/>
           </a:ln>
         </p:spPr>
+        <p:txBody>
+          <a:bodyPr/>
+          <a:lstStyle/>
+          <a:p>
+            <a:endParaRPr lang="en-CR"/>
+          </a:p>
+        </p:txBody>
       </p:sp>
       <p:sp>
         <p:nvSpPr>
@@ -8930,17 +9065,24 @@
             <a:prstDash val="solid"/>
           </a:ln>
         </p:spPr>
+        <p:txBody>
+          <a:bodyPr/>
+          <a:lstStyle/>
+          <a:p>
+            <a:endParaRPr lang="en-CR"/>
+          </a:p>
+        </p:txBody>
       </p:sp>
       <p:pic>
         <p:nvPicPr>
-          <p:cNvPr id="19" name="icon-FaMagic" descr="preencoded.png">    </p:cNvPr>
+          <p:cNvPr id="19" name="icon-FaMagic" descr="preencoded.png"/>
           <p:cNvPicPr>
             <a:picLocks noChangeAspect="1"/>
           </p:cNvPicPr>
           <p:nvPr/>
         </p:nvPicPr>
         <p:blipFill>
-          <a:blip r:embed="rId3"/>
+          <a:blip r:embed="rId5"/>
           <a:stretch>
             <a:fillRect/>
           </a:stretch>
@@ -8976,11 +9118,11 @@
           <a:bodyPr wrap="square" lIns="0" tIns="0" rIns="0" bIns="0" rtlCol="0" anchor="ctr"/>
           <a:lstStyle/>
           <a:p>
-            <a:pPr indent="0" marL="0">
-              <a:buNone/>
-            </a:pPr>
-            <a:r>
-              <a:rPr lang="en-US" sz="1100" b="1" spc="200" kern="0" dirty="0">
+            <a:pPr marL="0" indent="0">
+              <a:buNone/>
+            </a:pPr>
+            <a:r>
+              <a:rPr lang="en-US" sz="1100" b="1" kern="0" spc="200" dirty="0">
                 <a:solidFill>
                   <a:schemeClr val="accent6"/>
                 </a:solidFill>
@@ -9012,7 +9154,7 @@
           <a:bodyPr wrap="square" lIns="0" tIns="0" rIns="0" bIns="0" rtlCol="0" anchor="ctr"/>
           <a:lstStyle/>
           <a:p>
-            <a:pPr indent="0" marL="0">
+            <a:pPr marL="0" indent="0">
               <a:buNone/>
             </a:pPr>
             <a:r>
@@ -9048,7 +9190,7 @@
           <a:bodyPr wrap="square" lIns="0" tIns="0" rIns="0" bIns="0" rtlCol="0" anchor="t"/>
           <a:lstStyle/>
           <a:p>
-            <a:pPr indent="0" marL="0">
+            <a:pPr marL="0" indent="0">
               <a:buNone/>
             </a:pPr>
             <a:r>
@@ -9084,7 +9226,7 @@
           <a:bodyPr wrap="square" lIns="0" tIns="0" rIns="0" bIns="0" rtlCol="0" anchor="t"/>
           <a:lstStyle/>
           <a:p>
-            <a:pPr indent="0" marL="0">
+            <a:pPr marL="0" indent="0">
               <a:buNone/>
             </a:pPr>
             <a:r>
@@ -9123,6 +9265,13 @@
             <a:prstDash val="solid"/>
           </a:ln>
         </p:spPr>
+        <p:txBody>
+          <a:bodyPr/>
+          <a:lstStyle/>
+          <a:p>
+            <a:endParaRPr lang="en-CR"/>
+          </a:p>
+        </p:txBody>
       </p:sp>
       <p:sp>
         <p:nvSpPr>
@@ -9145,7 +9294,7 @@
           <a:bodyPr wrap="square" lIns="0" tIns="0" rIns="0" bIns="0" rtlCol="0" anchor="ctr"/>
           <a:lstStyle/>
           <a:p>
-            <a:pPr indent="0" marL="0">
+            <a:pPr marL="0" indent="0">
               <a:buNone/>
             </a:pPr>
             <a:r>
@@ -9181,7 +9330,7 @@
           <a:bodyPr wrap="square" lIns="0" tIns="0" rIns="0" bIns="0" rtlCol="0" anchor="ctr"/>
           <a:lstStyle/>
           <a:p>
-            <a:pPr algn="r" indent="0" marL="0">
+            <a:pPr marL="0" indent="0" algn="r">
               <a:buNone/>
             </a:pPr>
             <a:r>
@@ -9198,7 +9347,7 @@
       </p:sp>
       <p:sp>
         <p:nvSpPr>
-          <p:cNvPr id="25" name="Slide Number Placeholder 0"/>
+          <p:cNvPr id="27" name="Slide Number Placeholder 0"/>
           <p:cNvSpPr>
             <a:spLocks noGrp="1"/>
           </p:cNvSpPr>
@@ -9216,7 +9365,7 @@
           </a:prstGeom>
           <a:extLst>
             <a:ext uri="{C572A759-6A51-4108-AA02-DFA0A04FC94B}">
-              <ma14:wrappingTextBoxFlag xmlns:ma14="http://schemas.microsoft.com/office/mac/drawingml/2011/main" val="0"/>
+              <ma14:wrappingTextBoxFlag xmlns:ma14="http://schemas.microsoft.com/office/mac/drawingml/2011/main" xmlns="" val="0"/>
             </a:ext>
           </a:extLst>
         </p:spPr>
@@ -9234,7 +9383,7 @@
           <a:p>
             <a:pPr algn="r"/>
             <a:fld id="{F7021451-1387-4CA6-816F-3879F97B5CBC}" type="slidenum">
-              <a:rPr b="0" lang="en-US"/>
+              <a:rPr lang="en-US" b="0"/>
               <a:t>4</a:t>
             </a:fld>
             <a:endParaRPr lang="en-US"/>
@@ -9269,9 +9418,11 @@
       <p:sp>
         <p:nvSpPr>
           <p:cNvPr id="2" name="Text 0"/>
-          <p:cNvSpPr/>
+          <p:cNvSpPr>
+            <a:spLocks noGrp="1"/>
+          </p:cNvSpPr>
           <p:nvPr>
-            <p:ph idx="100" type="title" hasCustomPrompt="1"/>
+            <p:ph type="title" idx="100" hasCustomPrompt="1"/>
           </p:nvPr>
         </p:nvSpPr>
         <p:spPr>
@@ -9289,7 +9440,7 @@
           <a:bodyPr wrap="square" lIns="0" tIns="0" rIns="0" bIns="0" rtlCol="0" anchor="ctr"/>
           <a:lstStyle/>
           <a:p>
-            <a:pPr indent="0" marL="0">
+            <a:pPr marL="0" indent="0">
               <a:buNone/>
             </a:pPr>
             <a:r>
@@ -9306,14 +9457,14 @@
       </p:sp>
       <p:pic>
         <p:nvPicPr>
-          <p:cNvPr id="3" name="spec-anatomy" descr="img/spec-doc.png">    </p:cNvPr>
+          <p:cNvPr id="3" name="spec-anatomy" descr="img/spec-doc.png"/>
           <p:cNvPicPr>
             <a:picLocks noChangeAspect="1"/>
           </p:cNvPicPr>
           <p:nvPr/>
         </p:nvPicPr>
         <p:blipFill>
-          <a:blip r:embed="rId1"/>
+          <a:blip r:embed="rId3"/>
           <a:stretch>
             <a:fillRect/>
           </a:stretch>
@@ -9352,6 +9503,13 @@
             <a:prstDash val="solid"/>
           </a:ln>
         </p:spPr>
+        <p:txBody>
+          <a:bodyPr/>
+          <a:lstStyle/>
+          <a:p>
+            <a:endParaRPr lang="en-CR"/>
+          </a:p>
+        </p:txBody>
       </p:sp>
       <p:sp>
         <p:nvSpPr>
@@ -9374,7 +9532,7 @@
           <a:bodyPr wrap="square" lIns="0" tIns="0" rIns="0" bIns="0" rtlCol="0" anchor="ctr"/>
           <a:lstStyle/>
           <a:p>
-            <a:pPr indent="0" marL="0">
+            <a:pPr marL="0" indent="0">
               <a:buNone/>
             </a:pPr>
             <a:r>
@@ -9410,7 +9568,7 @@
           <a:bodyPr wrap="square" lIns="0" tIns="0" rIns="0" bIns="0" rtlCol="0" anchor="ctr"/>
           <a:lstStyle/>
           <a:p>
-            <a:pPr indent="0" marL="0">
+            <a:pPr marL="0" indent="0">
               <a:buNone/>
             </a:pPr>
             <a:r>
@@ -9449,6 +9607,13 @@
             <a:prstDash val="solid"/>
           </a:ln>
         </p:spPr>
+        <p:txBody>
+          <a:bodyPr/>
+          <a:lstStyle/>
+          <a:p>
+            <a:endParaRPr lang="en-CR"/>
+          </a:p>
+        </p:txBody>
       </p:sp>
       <p:sp>
         <p:nvSpPr>
@@ -9471,7 +9636,7 @@
           <a:bodyPr wrap="square" lIns="0" tIns="0" rIns="0" bIns="0" rtlCol="0" anchor="ctr"/>
           <a:lstStyle/>
           <a:p>
-            <a:pPr indent="0" marL="0">
+            <a:pPr marL="0" indent="0">
               <a:buNone/>
             </a:pPr>
             <a:r>
@@ -9507,7 +9672,7 @@
           <a:bodyPr wrap="square" lIns="0" tIns="0" rIns="0" bIns="0" rtlCol="0" anchor="ctr"/>
           <a:lstStyle/>
           <a:p>
-            <a:pPr indent="0" marL="0">
+            <a:pPr marL="0" indent="0">
               <a:buNone/>
             </a:pPr>
             <a:r>
@@ -9546,6 +9711,13 @@
             <a:prstDash val="solid"/>
           </a:ln>
         </p:spPr>
+        <p:txBody>
+          <a:bodyPr/>
+          <a:lstStyle/>
+          <a:p>
+            <a:endParaRPr lang="en-CR"/>
+          </a:p>
+        </p:txBody>
       </p:sp>
       <p:sp>
         <p:nvSpPr>
@@ -9568,7 +9740,7 @@
           <a:bodyPr wrap="square" lIns="0" tIns="0" rIns="0" bIns="0" rtlCol="0" anchor="ctr"/>
           <a:lstStyle/>
           <a:p>
-            <a:pPr indent="0" marL="0">
+            <a:pPr marL="0" indent="0">
               <a:buNone/>
             </a:pPr>
             <a:r>
@@ -9604,7 +9776,7 @@
           <a:bodyPr wrap="square" lIns="0" tIns="0" rIns="0" bIns="0" rtlCol="0" anchor="ctr"/>
           <a:lstStyle/>
           <a:p>
-            <a:pPr indent="0" marL="0">
+            <a:pPr marL="0" indent="0">
               <a:buNone/>
             </a:pPr>
             <a:r>
@@ -9643,6 +9815,13 @@
             <a:prstDash val="solid"/>
           </a:ln>
         </p:spPr>
+        <p:txBody>
+          <a:bodyPr/>
+          <a:lstStyle/>
+          <a:p>
+            <a:endParaRPr lang="en-CR"/>
+          </a:p>
+        </p:txBody>
       </p:sp>
       <p:sp>
         <p:nvSpPr>
@@ -9665,7 +9844,7 @@
           <a:bodyPr wrap="square" lIns="0" tIns="0" rIns="0" bIns="0" rtlCol="0" anchor="ctr"/>
           <a:lstStyle/>
           <a:p>
-            <a:pPr indent="0" marL="0">
+            <a:pPr marL="0" indent="0">
               <a:buNone/>
             </a:pPr>
             <a:r>
@@ -9701,7 +9880,7 @@
           <a:bodyPr wrap="square" lIns="0" tIns="0" rIns="0" bIns="0" rtlCol="0" anchor="ctr"/>
           <a:lstStyle/>
           <a:p>
-            <a:pPr indent="0" marL="0">
+            <a:pPr marL="0" indent="0">
               <a:buNone/>
             </a:pPr>
             <a:r>
@@ -9740,6 +9919,13 @@
             <a:prstDash val="solid"/>
           </a:ln>
         </p:spPr>
+        <p:txBody>
+          <a:bodyPr/>
+          <a:lstStyle/>
+          <a:p>
+            <a:endParaRPr lang="en-CR"/>
+          </a:p>
+        </p:txBody>
       </p:sp>
       <p:sp>
         <p:nvSpPr>
@@ -9762,7 +9948,7 @@
           <a:bodyPr wrap="square" lIns="0" tIns="0" rIns="0" bIns="0" rtlCol="0" anchor="ctr"/>
           <a:lstStyle/>
           <a:p>
-            <a:pPr indent="0" marL="0">
+            <a:pPr marL="0" indent="0">
               <a:buNone/>
             </a:pPr>
             <a:r>
@@ -9798,7 +9984,7 @@
           <a:bodyPr wrap="square" lIns="0" tIns="0" rIns="0" bIns="0" rtlCol="0" anchor="ctr"/>
           <a:lstStyle/>
           <a:p>
-            <a:pPr indent="0" marL="0">
+            <a:pPr marL="0" indent="0">
               <a:buNone/>
             </a:pPr>
             <a:r>
@@ -9833,7 +10019,7 @@
           </a:prstGeom>
           <a:extLst>
             <a:ext uri="{C572A759-6A51-4108-AA02-DFA0A04FC94B}">
-              <ma14:wrappingTextBoxFlag xmlns:ma14="http://schemas.microsoft.com/office/mac/drawingml/2011/main" val="0"/>
+              <ma14:wrappingTextBoxFlag xmlns:ma14="http://schemas.microsoft.com/office/mac/drawingml/2011/main" xmlns="" val="0"/>
             </a:ext>
           </a:extLst>
         </p:spPr>
@@ -9851,7 +10037,7 @@
           <a:p>
             <a:pPr algn="r"/>
             <a:fld id="{F7021451-1387-4CA6-816F-3879F97B5CBC}" type="slidenum">
-              <a:rPr b="0" lang="en-US"/>
+              <a:rPr lang="en-US" b="0"/>
               <a:t>5</a:t>
             </a:fld>
             <a:endParaRPr lang="en-US"/>
@@ -9886,9 +10072,11 @@
       <p:sp>
         <p:nvSpPr>
           <p:cNvPr id="2" name="Text 0"/>
-          <p:cNvSpPr/>
+          <p:cNvSpPr>
+            <a:spLocks noGrp="1"/>
+          </p:cNvSpPr>
           <p:nvPr>
-            <p:ph idx="100" type="title" hasCustomPrompt="1"/>
+            <p:ph type="title" idx="100" hasCustomPrompt="1"/>
           </p:nvPr>
         </p:nvSpPr>
         <p:spPr>
@@ -9906,7 +10094,7 @@
           <a:bodyPr wrap="square" lIns="0" tIns="0" rIns="0" bIns="0" rtlCol="0" anchor="ctr"/>
           <a:lstStyle/>
           <a:p>
-            <a:pPr indent="0" marL="0">
+            <a:pPr marL="0" indent="0">
               <a:buNone/>
             </a:pPr>
             <a:r>
@@ -9947,13 +10135,20 @@
             <a:prstDash val="solid"/>
           </a:ln>
           <a:effectLst>
-            <a:outerShdw sx="100000" sy="100000" kx="0" ky="0" algn="bl" rotWithShape="0" blurRad="101600" dist="25400" dir="5400000">
+            <a:outerShdw blurRad="101600" dist="25400" dir="5400000" algn="bl" rotWithShape="0">
               <a:srgbClr val="000000">
                 <a:alpha val="18000"/>
               </a:srgbClr>
             </a:outerShdw>
           </a:effectLst>
         </p:spPr>
+        <p:txBody>
+          <a:bodyPr/>
+          <a:lstStyle/>
+          <a:p>
+            <a:endParaRPr lang="en-CR"/>
+          </a:p>
+        </p:txBody>
       </p:sp>
       <p:sp>
         <p:nvSpPr>
@@ -9976,7 +10171,7 @@
           <a:bodyPr wrap="square" lIns="0" tIns="0" rIns="0" bIns="0" rtlCol="0" anchor="ctr"/>
           <a:lstStyle/>
           <a:p>
-            <a:pPr indent="0" marL="0">
+            <a:pPr marL="0" indent="0">
               <a:buNone/>
             </a:pPr>
             <a:r>
@@ -10015,7 +10210,7 @@
           <a:bodyPr wrap="square" lIns="0" tIns="0" rIns="0" bIns="0" rtlCol="0" anchor="t"/>
           <a:lstStyle/>
           <a:p>
-            <a:pPr indent="0" marL="0">
+            <a:pPr marL="0" indent="0">
               <a:spcAft>
                 <a:spcPts val="200"/>
               </a:spcAft>
@@ -10035,7 +10230,7 @@
             <a:endParaRPr lang="en-US" sz="1400" dirty="0"/>
           </a:p>
           <a:p>
-            <a:pPr indent="0" marL="0">
+            <a:pPr marL="0" indent="0">
               <a:spcAft>
                 <a:spcPts val="200"/>
               </a:spcAft>
@@ -10055,7 +10250,7 @@
             <a:endParaRPr lang="en-US" sz="1400" dirty="0"/>
           </a:p>
           <a:p>
-            <a:pPr indent="0" marL="0">
+            <a:pPr marL="0" indent="0">
               <a:spcAft>
                 <a:spcPts val="200"/>
               </a:spcAft>
@@ -10075,7 +10270,7 @@
             <a:endParaRPr lang="en-US" sz="1400" dirty="0"/>
           </a:p>
           <a:p>
-            <a:pPr indent="0" marL="0">
+            <a:pPr marL="0" indent="0">
               <a:spcAft>
                 <a:spcPts val="200"/>
               </a:spcAft>
@@ -10122,13 +10317,20 @@
             <a:prstDash val="solid"/>
           </a:ln>
           <a:effectLst>
-            <a:outerShdw sx="100000" sy="100000" kx="0" ky="0" algn="bl" rotWithShape="0" blurRad="101600" dist="25400" dir="5400000">
+            <a:outerShdw blurRad="101600" dist="25400" dir="5400000" algn="bl" rotWithShape="0">
               <a:srgbClr val="000000">
                 <a:alpha val="18000"/>
               </a:srgbClr>
             </a:outerShdw>
           </a:effectLst>
         </p:spPr>
+        <p:txBody>
+          <a:bodyPr/>
+          <a:lstStyle/>
+          <a:p>
+            <a:endParaRPr lang="en-CR"/>
+          </a:p>
+        </p:txBody>
       </p:sp>
       <p:sp>
         <p:nvSpPr>
@@ -10151,7 +10353,7 @@
           <a:bodyPr wrap="square" lIns="0" tIns="0" rIns="0" bIns="0" rtlCol="0" anchor="ctr"/>
           <a:lstStyle/>
           <a:p>
-            <a:pPr indent="0" marL="0">
+            <a:pPr marL="0" indent="0">
               <a:buNone/>
             </a:pPr>
             <a:r>
@@ -10190,7 +10392,7 @@
           <a:bodyPr wrap="square" lIns="0" tIns="0" rIns="0" bIns="0" rtlCol="0" anchor="t"/>
           <a:lstStyle/>
           <a:p>
-            <a:pPr indent="0" marL="0">
+            <a:pPr marL="0" indent="0">
               <a:spcAft>
                 <a:spcPts val="200"/>
               </a:spcAft>
@@ -10210,7 +10412,7 @@
             <a:endParaRPr lang="en-US" sz="1200" dirty="0"/>
           </a:p>
           <a:p>
-            <a:pPr indent="0" marL="0">
+            <a:pPr marL="0" indent="0">
               <a:spcAft>
                 <a:spcPts val="200"/>
               </a:spcAft>
@@ -10230,7 +10432,7 @@
             <a:endParaRPr lang="en-US" sz="1200" dirty="0"/>
           </a:p>
           <a:p>
-            <a:pPr indent="0" marL="0">
+            <a:pPr marL="0" indent="0">
               <a:spcAft>
                 <a:spcPts val="200"/>
               </a:spcAft>
@@ -10250,7 +10452,7 @@
             <a:endParaRPr lang="en-US" sz="1200" dirty="0"/>
           </a:p>
           <a:p>
-            <a:pPr indent="0" marL="0">
+            <a:pPr marL="0" indent="0">
               <a:spcAft>
                 <a:spcPts val="200"/>
               </a:spcAft>
@@ -10270,7 +10472,7 @@
             <a:endParaRPr lang="en-US" sz="1200" dirty="0"/>
           </a:p>
           <a:p>
-            <a:pPr indent="0" marL="0">
+            <a:pPr marL="0" indent="0">
               <a:spcAft>
                 <a:spcPts val="200"/>
               </a:spcAft>
@@ -10290,7 +10492,7 @@
             <a:endParaRPr lang="en-US" sz="1200" dirty="0"/>
           </a:p>
           <a:p>
-            <a:pPr indent="0" marL="0">
+            <a:pPr marL="0" indent="0">
               <a:spcAft>
                 <a:spcPts val="200"/>
               </a:spcAft>
@@ -10310,7 +10512,7 @@
             <a:endParaRPr lang="en-US" sz="1200" dirty="0"/>
           </a:p>
           <a:p>
-            <a:pPr indent="0" marL="0">
+            <a:pPr marL="0" indent="0">
               <a:spcAft>
                 <a:spcPts val="200"/>
               </a:spcAft>
@@ -10355,17 +10557,24 @@
             <a:prstDash val="solid"/>
           </a:ln>
         </p:spPr>
+        <p:txBody>
+          <a:bodyPr/>
+          <a:lstStyle/>
+          <a:p>
+            <a:endParaRPr lang="en-CR"/>
+          </a:p>
+        </p:txBody>
       </p:sp>
       <p:pic>
         <p:nvPicPr>
-          <p:cNvPr id="10" name="icon-FaTimes" descr="preencoded.png">    </p:cNvPr>
+          <p:cNvPr id="10" name="icon-FaTimes" descr="preencoded.png"/>
           <p:cNvPicPr>
             <a:picLocks noChangeAspect="1"/>
           </p:cNvPicPr>
           <p:nvPr/>
         </p:nvPicPr>
         <p:blipFill>
-          <a:blip r:embed="rId1"/>
+          <a:blip r:embed="rId3"/>
           <a:stretch>
             <a:fillRect/>
           </a:stretch>
@@ -10401,7 +10610,7 @@
           <a:bodyPr wrap="square" lIns="0" tIns="0" rIns="0" bIns="0" rtlCol="0" anchor="ctr"/>
           <a:lstStyle/>
           <a:p>
-            <a:pPr indent="0" marL="0">
+            <a:pPr marL="0" indent="0">
               <a:buNone/>
             </a:pPr>
             <a:r>
@@ -10440,17 +10649,24 @@
             <a:prstDash val="solid"/>
           </a:ln>
         </p:spPr>
+        <p:txBody>
+          <a:bodyPr/>
+          <a:lstStyle/>
+          <a:p>
+            <a:endParaRPr lang="en-CR"/>
+          </a:p>
+        </p:txBody>
       </p:sp>
       <p:pic>
         <p:nvPicPr>
-          <p:cNvPr id="13" name="icon-FaCheck" descr="preencoded.png">    </p:cNvPr>
+          <p:cNvPr id="13" name="icon-FaCheck" descr="preencoded.png"/>
           <p:cNvPicPr>
             <a:picLocks noChangeAspect="1"/>
           </p:cNvPicPr>
           <p:nvPr/>
         </p:nvPicPr>
         <p:blipFill>
-          <a:blip r:embed="rId2"/>
+          <a:blip r:embed="rId4"/>
           <a:stretch>
             <a:fillRect/>
           </a:stretch>
@@ -10486,7 +10702,7 @@
           <a:bodyPr wrap="square" lIns="0" tIns="0" rIns="0" bIns="0" rtlCol="0" anchor="ctr"/>
           <a:lstStyle/>
           <a:p>
-            <a:pPr indent="0" marL="0">
+            <a:pPr marL="0" indent="0">
               <a:buNone/>
             </a:pPr>
             <a:r>
@@ -10521,7 +10737,7 @@
           </a:prstGeom>
           <a:extLst>
             <a:ext uri="{C572A759-6A51-4108-AA02-DFA0A04FC94B}">
-              <ma14:wrappingTextBoxFlag xmlns:ma14="http://schemas.microsoft.com/office/mac/drawingml/2011/main" val="0"/>
+              <ma14:wrappingTextBoxFlag xmlns:ma14="http://schemas.microsoft.com/office/mac/drawingml/2011/main" xmlns="" val="0"/>
             </a:ext>
           </a:extLst>
         </p:spPr>
@@ -10539,7 +10755,7 @@
           <a:p>
             <a:pPr algn="r"/>
             <a:fld id="{F7021451-1387-4CA6-816F-3879F97B5CBC}" type="slidenum">
-              <a:rPr b="0" lang="en-US"/>
+              <a:rPr lang="en-US" b="0"/>
               <a:t>6</a:t>
             </a:fld>
             <a:endParaRPr lang="en-US"/>
@@ -10574,9 +10790,11 @@
       <p:sp>
         <p:nvSpPr>
           <p:cNvPr id="2" name="Text 0"/>
-          <p:cNvSpPr/>
+          <p:cNvSpPr>
+            <a:spLocks noGrp="1"/>
+          </p:cNvSpPr>
           <p:nvPr>
-            <p:ph idx="100" type="title" hasCustomPrompt="1"/>
+            <p:ph type="title" idx="100" hasCustomPrompt="1"/>
           </p:nvPr>
         </p:nvSpPr>
         <p:spPr>
@@ -10594,7 +10812,7 @@
           <a:bodyPr wrap="square" lIns="0" tIns="0" rIns="0" bIns="0" rtlCol="0" anchor="ctr"/>
           <a:lstStyle/>
           <a:p>
-            <a:pPr indent="0" marL="0">
+            <a:pPr marL="0" indent="0">
               <a:buNone/>
             </a:pPr>
             <a:r>
@@ -10611,14 +10829,14 @@
       </p:sp>
       <p:pic>
         <p:nvPicPr>
-          <p:cNvPr id="3" name="sdd-loop" descr="img/sdd-loop.png">    </p:cNvPr>
+          <p:cNvPr id="3" name="sdd-loop" descr="img/sdd-loop.png"/>
           <p:cNvPicPr>
             <a:picLocks noChangeAspect="1"/>
           </p:cNvPicPr>
           <p:nvPr/>
         </p:nvPicPr>
         <p:blipFill>
-          <a:blip r:embed="rId1"/>
+          <a:blip r:embed="rId3"/>
           <a:stretch>
             <a:fillRect/>
           </a:stretch>
@@ -10669,12 +10887,6 @@
               </a:rPr>
               <a:t>Each arrow is a review</a:t>
             </a:r>
-            <a:pPr indent="0" marL="0">
-              <a:spcAft>
-                <a:spcPts val="1000"/>
-              </a:spcAft>
-              <a:buNone/>
-            </a:pPr>
             <a:r>
               <a:rPr lang="en-US" sz="1700" dirty="0">
                 <a:solidFill>
@@ -10701,12 +10913,6 @@
               </a:rPr>
               <a:t>Change the spec,</a:t>
             </a:r>
-            <a:pPr indent="0" marL="0">
-              <a:spcAft>
-                <a:spcPts val="1000"/>
-              </a:spcAft>
-              <a:buNone/>
-            </a:pPr>
             <a:r>
               <a:rPr lang="en-US" sz="1700" dirty="0">
                 <a:solidFill>
@@ -10733,12 +10939,6 @@
               </a:rPr>
               <a:t>Verify against the spec,</a:t>
             </a:r>
-            <a:pPr indent="0" marL="0">
-              <a:spcAft>
-                <a:spcPts val="1000"/>
-              </a:spcAft>
-              <a:buNone/>
-            </a:pPr>
             <a:r>
               <a:rPr lang="en-US" sz="1700" dirty="0">
                 <a:solidFill>
@@ -10765,12 +10965,6 @@
               </a:rPr>
               <a:t>Spec ≠ code?</a:t>
             </a:r>
-            <a:pPr indent="0" marL="0">
-              <a:spcAft>
-                <a:spcPts val="1000"/>
-              </a:spcAft>
-              <a:buNone/>
-            </a:pPr>
             <a:r>
               <a:rPr lang="en-US" sz="1700" dirty="0">
                 <a:solidFill>
@@ -10803,7 +10997,7 @@
           </a:prstGeom>
           <a:extLst>
             <a:ext uri="{C572A759-6A51-4108-AA02-DFA0A04FC94B}">
-              <ma14:wrappingTextBoxFlag xmlns:ma14="http://schemas.microsoft.com/office/mac/drawingml/2011/main" val="0"/>
+              <ma14:wrappingTextBoxFlag xmlns:ma14="http://schemas.microsoft.com/office/mac/drawingml/2011/main" xmlns="" val="0"/>
             </a:ext>
           </a:extLst>
         </p:spPr>
@@ -10821,7 +11015,7 @@
           <a:p>
             <a:pPr algn="r"/>
             <a:fld id="{F7021451-1387-4CA6-816F-3879F97B5CBC}" type="slidenum">
-              <a:rPr b="0" lang="en-US"/>
+              <a:rPr lang="en-US" b="0"/>
               <a:t>7</a:t>
             </a:fld>
             <a:endParaRPr lang="en-US"/>
@@ -10856,9 +11050,11 @@
       <p:sp>
         <p:nvSpPr>
           <p:cNvPr id="2" name="Text 0"/>
-          <p:cNvSpPr/>
+          <p:cNvSpPr>
+            <a:spLocks noGrp="1"/>
+          </p:cNvSpPr>
           <p:nvPr>
-            <p:ph idx="100" type="title" hasCustomPrompt="1"/>
+            <p:ph type="title" idx="100" hasCustomPrompt="1"/>
           </p:nvPr>
         </p:nvSpPr>
         <p:spPr>
@@ -10876,7 +11072,7 @@
           <a:bodyPr wrap="square" lIns="0" tIns="0" rIns="0" bIns="0" rtlCol="0" anchor="ctr"/>
           <a:lstStyle/>
           <a:p>
-            <a:pPr indent="0" marL="0">
+            <a:pPr marL="0" indent="0">
               <a:buNone/>
             </a:pPr>
             <a:r>
@@ -10917,6 +11113,13 @@
             <a:prstDash val="solid"/>
           </a:ln>
         </p:spPr>
+        <p:txBody>
+          <a:bodyPr/>
+          <a:lstStyle/>
+          <a:p>
+            <a:endParaRPr lang="en-CR"/>
+          </a:p>
+        </p:txBody>
       </p:sp>
       <p:sp>
         <p:nvSpPr>
@@ -10942,17 +11145,24 @@
             <a:prstDash val="solid"/>
           </a:ln>
         </p:spPr>
+        <p:txBody>
+          <a:bodyPr/>
+          <a:lstStyle/>
+          <a:p>
+            <a:endParaRPr lang="en-CR"/>
+          </a:p>
+        </p:txBody>
       </p:sp>
       <p:pic>
         <p:nvPicPr>
-          <p:cNvPr id="5" name="icon-FaKeyboard" descr="preencoded.png">    </p:cNvPr>
+          <p:cNvPr id="5" name="icon-FaKeyboard" descr="preencoded.png"/>
           <p:cNvPicPr>
             <a:picLocks noChangeAspect="1"/>
           </p:cNvPicPr>
           <p:nvPr/>
         </p:nvPicPr>
         <p:blipFill>
-          <a:blip r:embed="rId1"/>
+          <a:blip r:embed="rId3"/>
           <a:stretch>
             <a:fillRect/>
           </a:stretch>
@@ -10988,7 +11198,7 @@
           <a:bodyPr wrap="square" lIns="0" tIns="0" rIns="0" bIns="0" rtlCol="0" anchor="ctr"/>
           <a:lstStyle/>
           <a:p>
-            <a:pPr indent="0" marL="0">
+            <a:pPr marL="0" indent="0">
               <a:buNone/>
             </a:pPr>
             <a:r>
@@ -11024,7 +11234,7 @@
           <a:bodyPr wrap="square" lIns="0" tIns="0" rIns="0" bIns="0" rtlCol="0" anchor="t"/>
           <a:lstStyle/>
           <a:p>
-            <a:pPr indent="0" marL="0">
+            <a:pPr marL="0" indent="0">
               <a:buNone/>
             </a:pPr>
             <a:r>
@@ -11063,6 +11273,13 @@
             <a:prstDash val="solid"/>
           </a:ln>
         </p:spPr>
+        <p:txBody>
+          <a:bodyPr/>
+          <a:lstStyle/>
+          <a:p>
+            <a:endParaRPr lang="en-CR"/>
+          </a:p>
+        </p:txBody>
       </p:sp>
       <p:sp>
         <p:nvSpPr>
@@ -11085,7 +11302,7 @@
           <a:bodyPr wrap="square" lIns="0" tIns="0" rIns="0" bIns="0" rtlCol="0" anchor="ctr"/>
           <a:lstStyle/>
           <a:p>
-            <a:pPr algn="ctr" indent="0" marL="0">
+            <a:pPr marL="0" indent="0" algn="ctr">
               <a:buNone/>
             </a:pPr>
             <a:r>
@@ -11126,6 +11343,13 @@
             <a:prstDash val="solid"/>
           </a:ln>
         </p:spPr>
+        <p:txBody>
+          <a:bodyPr/>
+          <a:lstStyle/>
+          <a:p>
+            <a:endParaRPr lang="en-CR"/>
+          </a:p>
+        </p:txBody>
       </p:sp>
       <p:sp>
         <p:nvSpPr>
@@ -11151,17 +11375,24 @@
             <a:prstDash val="solid"/>
           </a:ln>
         </p:spPr>
+        <p:txBody>
+          <a:bodyPr/>
+          <a:lstStyle/>
+          <a:p>
+            <a:endParaRPr lang="en-CR"/>
+          </a:p>
+        </p:txBody>
       </p:sp>
       <p:pic>
         <p:nvPicPr>
-          <p:cNvPr id="12" name="icon-FaComments" descr="preencoded.png">    </p:cNvPr>
+          <p:cNvPr id="12" name="icon-FaComments" descr="preencoded.png"/>
           <p:cNvPicPr>
             <a:picLocks noChangeAspect="1"/>
           </p:cNvPicPr>
           <p:nvPr/>
         </p:nvPicPr>
         <p:blipFill>
-          <a:blip r:embed="rId2"/>
+          <a:blip r:embed="rId4"/>
           <a:stretch>
             <a:fillRect/>
           </a:stretch>
@@ -11197,7 +11428,7 @@
           <a:bodyPr wrap="square" lIns="0" tIns="0" rIns="0" bIns="0" rtlCol="0" anchor="ctr"/>
           <a:lstStyle/>
           <a:p>
-            <a:pPr indent="0" marL="0">
+            <a:pPr marL="0" indent="0">
               <a:buNone/>
             </a:pPr>
             <a:r>
@@ -11233,7 +11464,7 @@
           <a:bodyPr wrap="square" lIns="0" tIns="0" rIns="0" bIns="0" rtlCol="0" anchor="t"/>
           <a:lstStyle/>
           <a:p>
-            <a:pPr indent="0" marL="0">
+            <a:pPr marL="0" indent="0">
               <a:buNone/>
             </a:pPr>
             <a:r>
@@ -11272,6 +11503,13 @@
             <a:prstDash val="solid"/>
           </a:ln>
         </p:spPr>
+        <p:txBody>
+          <a:bodyPr/>
+          <a:lstStyle/>
+          <a:p>
+            <a:endParaRPr lang="en-CR"/>
+          </a:p>
+        </p:txBody>
       </p:sp>
       <p:sp>
         <p:nvSpPr>
@@ -11294,7 +11532,7 @@
           <a:bodyPr wrap="square" lIns="0" tIns="0" rIns="0" bIns="0" rtlCol="0" anchor="ctr"/>
           <a:lstStyle/>
           <a:p>
-            <a:pPr algn="ctr" indent="0" marL="0">
+            <a:pPr marL="0" indent="0" algn="ctr">
               <a:buNone/>
             </a:pPr>
             <a:r>
@@ -11335,6 +11573,13 @@
             <a:prstDash val="solid"/>
           </a:ln>
         </p:spPr>
+        <p:txBody>
+          <a:bodyPr/>
+          <a:lstStyle/>
+          <a:p>
+            <a:endParaRPr lang="en-CR"/>
+          </a:p>
+        </p:txBody>
       </p:sp>
       <p:sp>
         <p:nvSpPr>
@@ -11360,17 +11605,24 @@
             <a:prstDash val="solid"/>
           </a:ln>
         </p:spPr>
+        <p:txBody>
+          <a:bodyPr/>
+          <a:lstStyle/>
+          <a:p>
+            <a:endParaRPr lang="en-CR"/>
+          </a:p>
+        </p:txBody>
       </p:sp>
       <p:pic>
         <p:nvPicPr>
-          <p:cNvPr id="19" name="icon-FaRobot" descr="preencoded.png">    </p:cNvPr>
+          <p:cNvPr id="19" name="icon-FaRobot" descr="preencoded.png"/>
           <p:cNvPicPr>
             <a:picLocks noChangeAspect="1"/>
           </p:cNvPicPr>
           <p:nvPr/>
         </p:nvPicPr>
         <p:blipFill>
-          <a:blip r:embed="rId3"/>
+          <a:blip r:embed="rId5"/>
           <a:stretch>
             <a:fillRect/>
           </a:stretch>
@@ -11406,7 +11658,7 @@
           <a:bodyPr wrap="square" lIns="0" tIns="0" rIns="0" bIns="0" rtlCol="0" anchor="ctr"/>
           <a:lstStyle/>
           <a:p>
-            <a:pPr indent="0" marL="0">
+            <a:pPr marL="0" indent="0">
               <a:buNone/>
             </a:pPr>
             <a:r>
@@ -11442,7 +11694,7 @@
           <a:bodyPr wrap="square" lIns="0" tIns="0" rIns="0" bIns="0" rtlCol="0" anchor="t"/>
           <a:lstStyle/>
           <a:p>
-            <a:pPr indent="0" marL="0">
+            <a:pPr marL="0" indent="0">
               <a:buNone/>
             </a:pPr>
             <a:r>
@@ -11478,7 +11730,7 @@
           <a:bodyPr wrap="square" lIns="0" tIns="0" rIns="0" bIns="0" rtlCol="0" anchor="ctr"/>
           <a:lstStyle/>
           <a:p>
-            <a:pPr algn="ctr" indent="0" marL="0">
+            <a:pPr marL="0" indent="0" algn="ctr">
               <a:buNone/>
             </a:pPr>
             <a:r>
@@ -11513,7 +11765,7 @@
           </a:prstGeom>
           <a:extLst>
             <a:ext uri="{C572A759-6A51-4108-AA02-DFA0A04FC94B}">
-              <ma14:wrappingTextBoxFlag xmlns:ma14="http://schemas.microsoft.com/office/mac/drawingml/2011/main" val="0"/>
+              <ma14:wrappingTextBoxFlag xmlns:ma14="http://schemas.microsoft.com/office/mac/drawingml/2011/main" xmlns="" val="0"/>
             </a:ext>
           </a:extLst>
         </p:spPr>
@@ -11531,7 +11783,7 @@
           <a:p>
             <a:pPr algn="r"/>
             <a:fld id="{F7021451-1387-4CA6-816F-3879F97B5CBC}" type="slidenum">
-              <a:rPr b="0" lang="en-US"/>
+              <a:rPr lang="en-US" b="0"/>
               <a:t>8</a:t>
             </a:fld>
             <a:endParaRPr lang="en-US"/>
@@ -11566,9 +11818,11 @@
       <p:sp>
         <p:nvSpPr>
           <p:cNvPr id="2" name="Text 0"/>
-          <p:cNvSpPr/>
+          <p:cNvSpPr>
+            <a:spLocks noGrp="1"/>
+          </p:cNvSpPr>
           <p:nvPr>
-            <p:ph idx="100" type="title" hasCustomPrompt="1"/>
+            <p:ph type="title" idx="100" hasCustomPrompt="1"/>
           </p:nvPr>
         </p:nvSpPr>
         <p:spPr>
@@ -11586,7 +11840,7 @@
           <a:bodyPr wrap="square" lIns="0" tIns="0" rIns="0" bIns="0" rtlCol="0" anchor="ctr"/>
           <a:lstStyle/>
           <a:p>
-            <a:pPr indent="0" marL="0">
+            <a:pPr marL="0" indent="0">
               <a:buNone/>
             </a:pPr>
             <a:r>
@@ -11603,14 +11857,14 @@
       </p:sp>
       <p:pic>
         <p:nvPicPr>
-          <p:cNvPr id="3" name="agent-loop" descr="img/agent-loop.png">    </p:cNvPr>
+          <p:cNvPr id="3" name="agent-loop" descr="img/agent-loop.png"/>
           <p:cNvPicPr>
             <a:picLocks noChangeAspect="1"/>
           </p:cNvPicPr>
           <p:nvPr/>
         </p:nvPicPr>
         <p:blipFill>
-          <a:blip r:embed="rId1"/>
+          <a:blip r:embed="rId3"/>
           <a:stretch>
             <a:fillRect/>
           </a:stretch>
@@ -11649,17 +11903,24 @@
             <a:prstDash val="solid"/>
           </a:ln>
         </p:spPr>
+        <p:txBody>
+          <a:bodyPr/>
+          <a:lstStyle/>
+          <a:p>
+            <a:endParaRPr lang="en-CR"/>
+          </a:p>
+        </p:txBody>
       </p:sp>
       <p:pic>
         <p:nvPicPr>
-          <p:cNvPr id="5" name="icon-FaTerminal" descr="preencoded.png">    </p:cNvPr>
+          <p:cNvPr id="5" name="icon-FaTerminal" descr="preencoded.png"/>
           <p:cNvPicPr>
             <a:picLocks noChangeAspect="1"/>
           </p:cNvPicPr>
           <p:nvPr/>
         </p:nvPicPr>
         <p:blipFill>
-          <a:blip r:embed="rId2"/>
+          <a:blip r:embed="rId4"/>
           <a:stretch>
             <a:fillRect/>
           </a:stretch>
@@ -11695,7 +11956,7 @@
           <a:bodyPr wrap="square" lIns="0" tIns="0" rIns="0" bIns="0" rtlCol="0" anchor="ctr"/>
           <a:lstStyle/>
           <a:p>
-            <a:pPr indent="0" marL="0">
+            <a:pPr marL="0" indent="0">
               <a:buNone/>
             </a:pPr>
             <a:r>
@@ -11734,17 +11995,24 @@
             <a:prstDash val="solid"/>
           </a:ln>
         </p:spPr>
+        <p:txBody>
+          <a:bodyPr/>
+          <a:lstStyle/>
+          <a:p>
+            <a:endParaRPr lang="en-CR"/>
+          </a:p>
+        </p:txBody>
       </p:sp>
       <p:pic>
         <p:nvPicPr>
-          <p:cNvPr id="8" name="icon-FaFileCode" descr="preencoded.png">    </p:cNvPr>
+          <p:cNvPr id="8" name="icon-FaFileCode" descr="preencoded.png"/>
           <p:cNvPicPr>
             <a:picLocks noChangeAspect="1"/>
           </p:cNvPicPr>
           <p:nvPr/>
         </p:nvPicPr>
         <p:blipFill>
-          <a:blip r:embed="rId3"/>
+          <a:blip r:embed="rId5"/>
           <a:stretch>
             <a:fillRect/>
           </a:stretch>
@@ -11780,7 +12048,7 @@
           <a:bodyPr wrap="square" lIns="0" tIns="0" rIns="0" bIns="0" rtlCol="0" anchor="ctr"/>
           <a:lstStyle/>
           <a:p>
-            <a:pPr indent="0" marL="0">
+            <a:pPr marL="0" indent="0">
               <a:buNone/>
             </a:pPr>
             <a:r>
@@ -11819,17 +12087,24 @@
             <a:prstDash val="solid"/>
           </a:ln>
         </p:spPr>
+        <p:txBody>
+          <a:bodyPr/>
+          <a:lstStyle/>
+          <a:p>
+            <a:endParaRPr lang="en-CR"/>
+          </a:p>
+        </p:txBody>
       </p:sp>
       <p:pic>
         <p:nvPicPr>
-          <p:cNvPr id="11" name="icon-FaVial" descr="preencoded.png">    </p:cNvPr>
+          <p:cNvPr id="11" name="icon-FaVial" descr="preencoded.png"/>
           <p:cNvPicPr>
             <a:picLocks noChangeAspect="1"/>
           </p:cNvPicPr>
           <p:nvPr/>
         </p:nvPicPr>
         <p:blipFill>
-          <a:blip r:embed="rId4"/>
+          <a:blip r:embed="rId6"/>
           <a:stretch>
             <a:fillRect/>
           </a:stretch>
@@ -11865,7 +12140,7 @@
           <a:bodyPr wrap="square" lIns="0" tIns="0" rIns="0" bIns="0" rtlCol="0" anchor="ctr"/>
           <a:lstStyle/>
           <a:p>
-            <a:pPr indent="0" marL="0">
+            <a:pPr marL="0" indent="0">
               <a:buNone/>
             </a:pPr>
             <a:r>
@@ -11904,17 +12179,24 @@
             <a:prstDash val="solid"/>
           </a:ln>
         </p:spPr>
+        <p:txBody>
+          <a:bodyPr/>
+          <a:lstStyle/>
+          <a:p>
+            <a:endParaRPr lang="en-CR"/>
+          </a:p>
+        </p:txBody>
       </p:sp>
       <p:pic>
         <p:nvPicPr>
-          <p:cNvPr id="14" name="icon-FaGlobe" descr="preencoded.png">    </p:cNvPr>
+          <p:cNvPr id="14" name="icon-FaGlobe" descr="preencoded.png"/>
           <p:cNvPicPr>
             <a:picLocks noChangeAspect="1"/>
           </p:cNvPicPr>
           <p:nvPr/>
         </p:nvPicPr>
         <p:blipFill>
-          <a:blip r:embed="rId5"/>
+          <a:blip r:embed="rId7"/>
           <a:stretch>
             <a:fillRect/>
           </a:stretch>
@@ -11950,7 +12232,7 @@
           <a:bodyPr wrap="square" lIns="0" tIns="0" rIns="0" bIns="0" rtlCol="0" anchor="ctr"/>
           <a:lstStyle/>
           <a:p>
-            <a:pPr indent="0" marL="0">
+            <a:pPr marL="0" indent="0">
               <a:buNone/>
             </a:pPr>
             <a:r>
@@ -12001,12 +12283,6 @@
               </a:rPr>
               <a:t>An LLM in a loop</a:t>
             </a:r>
-            <a:pPr indent="0" marL="0">
-              <a:spcAft>
-                <a:spcPts val="1000"/>
-              </a:spcAft>
-              <a:buNone/>
-            </a:pPr>
             <a:r>
               <a:rPr lang="en-US" sz="1600" dirty="0">
                 <a:solidFill>
@@ -12033,12 +12309,6 @@
               </a:rPr>
               <a:t>Stops when the goal looks met</a:t>
             </a:r>
-            <a:pPr indent="0" marL="0">
-              <a:spcAft>
-                <a:spcPts val="1000"/>
-              </a:spcAft>
-              <a:buNone/>
-            </a:pPr>
             <a:r>
               <a:rPr lang="en-US" sz="1600" dirty="0">
                 <a:solidFill>
@@ -12065,12 +12335,6 @@
               </a:rPr>
               <a:t>Quality =</a:t>
             </a:r>
-            <a:pPr indent="0" marL="0">
-              <a:spcAft>
-                <a:spcPts val="1000"/>
-              </a:spcAft>
-              <a:buNone/>
-            </a:pPr>
             <a:r>
               <a:rPr lang="en-US" sz="1600" dirty="0">
                 <a:solidFill>
@@ -12103,7 +12367,7 @@
           </a:prstGeom>
           <a:extLst>
             <a:ext uri="{C572A759-6A51-4108-AA02-DFA0A04FC94B}">
-              <ma14:wrappingTextBoxFlag xmlns:ma14="http://schemas.microsoft.com/office/mac/drawingml/2011/main" val="0"/>
+              <ma14:wrappingTextBoxFlag xmlns:ma14="http://schemas.microsoft.com/office/mac/drawingml/2011/main" xmlns="" val="0"/>
             </a:ext>
           </a:extLst>
         </p:spPr>
@@ -12121,7 +12385,7 @@
           <a:p>
             <a:pPr algn="r"/>
             <a:fld id="{F7021451-1387-4CA6-816F-3879F97B5CBC}" type="slidenum">
-              <a:rPr b="0" lang="en-US"/>
+              <a:rPr lang="en-US" b="0"/>
               <a:t>9</a:t>
             </a:fld>
             <a:endParaRPr lang="en-US"/>
@@ -12429,4 +12693,319 @@
     </a:ext>
   </a:extLst>
 </a:theme>
+</file>
+
+<file path=ppt/theme/theme2.xml><?xml version="1.0" encoding="utf-8"?>
+<a:theme xmlns:a="http://schemas.openxmlformats.org/drawingml/2006/main" name="Office Theme">
+  <a:themeElements>
+    <a:clrScheme name="Office">
+      <a:dk1>
+        <a:sysClr val="windowText" lastClr="000000"/>
+      </a:dk1>
+      <a:lt1>
+        <a:sysClr val="window" lastClr="FFFFFF"/>
+      </a:lt1>
+      <a:dk2>
+        <a:srgbClr val="0E2841"/>
+      </a:dk2>
+      <a:lt2>
+        <a:srgbClr val="E8E8E8"/>
+      </a:lt2>
+      <a:accent1>
+        <a:srgbClr val="156082"/>
+      </a:accent1>
+      <a:accent2>
+        <a:srgbClr val="E97132"/>
+      </a:accent2>
+      <a:accent3>
+        <a:srgbClr val="196B24"/>
+      </a:accent3>
+      <a:accent4>
+        <a:srgbClr val="0F9ED5"/>
+      </a:accent4>
+      <a:accent5>
+        <a:srgbClr val="A02B93"/>
+      </a:accent5>
+      <a:accent6>
+        <a:srgbClr val="4EA72E"/>
+      </a:accent6>
+      <a:hlink>
+        <a:srgbClr val="467886"/>
+      </a:hlink>
+      <a:folHlink>
+        <a:srgbClr val="96607D"/>
+      </a:folHlink>
+    </a:clrScheme>
+    <a:fontScheme name="Office">
+      <a:majorFont>
+        <a:latin typeface="Aptos Display" panose="02110004020202020204"/>
+        <a:ea typeface=""/>
+        <a:cs typeface=""/>
+        <a:font script="Jpan" typeface="游ゴシック Light"/>
+        <a:font script="Hang" typeface="맑은 고딕"/>
+        <a:font script="Hans" typeface="等线 Light"/>
+        <a:font script="Hant" typeface="新細明體"/>
+        <a:font script="Arab" typeface="Times New Roman"/>
+        <a:font script="Hebr" typeface="Times New Roman"/>
+        <a:font script="Thai" typeface="Angsana New"/>
+        <a:font script="Ethi" typeface="Nyala"/>
+        <a:font script="Beng" typeface="Vrinda"/>
+        <a:font script="Gujr" typeface="Shruti"/>
+        <a:font script="Khmr" typeface="MoolBoran"/>
+        <a:font script="Knda" typeface="Tunga"/>
+        <a:font script="Guru" typeface="Raavi"/>
+        <a:font script="Cans" typeface="Euphemia"/>
+        <a:font script="Cher" typeface="Plantagenet Cherokee"/>
+        <a:font script="Yiii" typeface="Microsoft Yi Baiti"/>
+        <a:font script="Tibt" typeface="Microsoft Himalaya"/>
+        <a:font script="Thaa" typeface="MV Boli"/>
+        <a:font script="Deva" typeface="Mangal"/>
+        <a:font script="Telu" typeface="Gautami"/>
+        <a:font script="Taml" typeface="Latha"/>
+        <a:font script="Syrc" typeface="Estrangelo Edessa"/>
+        <a:font script="Orya" typeface="Kalinga"/>
+        <a:font script="Mlym" typeface="Kartika"/>
+        <a:font script="Laoo" typeface="DokChampa"/>
+        <a:font script="Sinh" typeface="Iskoola Pota"/>
+        <a:font script="Mong" typeface="Mongolian Baiti"/>
+        <a:font script="Viet" typeface="Times New Roman"/>
+        <a:font script="Uigh" typeface="Microsoft Uighur"/>
+        <a:font script="Geor" typeface="Sylfaen"/>
+        <a:font script="Armn" typeface="Arial"/>
+        <a:font script="Bugi" typeface="Leelawadee UI"/>
+        <a:font script="Bopo" typeface="Microsoft JhengHei"/>
+        <a:font script="Java" typeface="Javanese Text"/>
+        <a:font script="Lisu" typeface="Segoe UI"/>
+        <a:font script="Mymr" typeface="Myanmar Text"/>
+        <a:font script="Nkoo" typeface="Ebrima"/>
+        <a:font script="Olck" typeface="Nirmala UI"/>
+        <a:font script="Osma" typeface="Ebrima"/>
+        <a:font script="Phag" typeface="Phagspa"/>
+        <a:font script="Syrn" typeface="Estrangelo Edessa"/>
+        <a:font script="Syrj" typeface="Estrangelo Edessa"/>
+        <a:font script="Syre" typeface="Estrangelo Edessa"/>
+        <a:font script="Sora" typeface="Nirmala UI"/>
+        <a:font script="Tale" typeface="Microsoft Tai Le"/>
+        <a:font script="Talu" typeface="Microsoft New Tai Lue"/>
+        <a:font script="Tfng" typeface="Ebrima"/>
+      </a:majorFont>
+      <a:minorFont>
+        <a:latin typeface="Aptos" panose="02110004020202020204"/>
+        <a:ea typeface=""/>
+        <a:cs typeface=""/>
+        <a:font script="Jpan" typeface="游ゴシック"/>
+        <a:font script="Hang" typeface="맑은 고딕"/>
+        <a:font script="Hans" typeface="等线"/>
+        <a:font script="Hant" typeface="新細明體"/>
+        <a:font script="Arab" typeface="Arial"/>
+        <a:font script="Hebr" typeface="Arial"/>
+        <a:font script="Thai" typeface="Cordia New"/>
+        <a:font script="Ethi" typeface="Nyala"/>
+        <a:font script="Beng" typeface="Vrinda"/>
+        <a:font script="Gujr" typeface="Shruti"/>
+        <a:font script="Khmr" typeface="DaunPenh"/>
+        <a:font script="Knda" typeface="Tunga"/>
+        <a:font script="Guru" typeface="Raavi"/>
+        <a:font script="Cans" typeface="Euphemia"/>
+        <a:font script="Cher" typeface="Plantagenet Cherokee"/>
+        <a:font script="Yiii" typeface="Microsoft Yi Baiti"/>
+        <a:font script="Tibt" typeface="Microsoft Himalaya"/>
+        <a:font script="Thaa" typeface="MV Boli"/>
+        <a:font script="Deva" typeface="Mangal"/>
+        <a:font script="Telu" typeface="Gautami"/>
+        <a:font script="Taml" typeface="Latha"/>
+        <a:font script="Syrc" typeface="Estrangelo Edessa"/>
+        <a:font script="Orya" typeface="Kalinga"/>
+        <a:font script="Mlym" typeface="Kartika"/>
+        <a:font script="Laoo" typeface="DokChampa"/>
+        <a:font script="Sinh" typeface="Iskoola Pota"/>
+        <a:font script="Mong" typeface="Mongolian Baiti"/>
+        <a:font script="Viet" typeface="Arial"/>
+        <a:font script="Uigh" typeface="Microsoft Uighur"/>
+        <a:font script="Geor" typeface="Sylfaen"/>
+        <a:font script="Armn" typeface="Arial"/>
+        <a:font script="Bugi" typeface="Leelawadee UI"/>
+        <a:font script="Bopo" typeface="Microsoft JhengHei"/>
+        <a:font script="Java" typeface="Javanese Text"/>
+        <a:font script="Lisu" typeface="Segoe UI"/>
+        <a:font script="Mymr" typeface="Myanmar Text"/>
+        <a:font script="Nkoo" typeface="Ebrima"/>
+        <a:font script="Olck" typeface="Nirmala UI"/>
+        <a:font script="Osma" typeface="Ebrima"/>
+        <a:font script="Phag" typeface="Phagspa"/>
+        <a:font script="Syrn" typeface="Estrangelo Edessa"/>
+        <a:font script="Syrj" typeface="Estrangelo Edessa"/>
+        <a:font script="Syre" typeface="Estrangelo Edessa"/>
+        <a:font script="Sora" typeface="Nirmala UI"/>
+        <a:font script="Tale" typeface="Microsoft Tai Le"/>
+        <a:font script="Talu" typeface="Microsoft New Tai Lue"/>
+        <a:font script="Tfng" typeface="Ebrima"/>
+      </a:minorFont>
+    </a:fontScheme>
+    <a:fmtScheme name="Office">
+      <a:fillStyleLst>
+        <a:solidFill>
+          <a:schemeClr val="phClr"/>
+        </a:solidFill>
+        <a:gradFill rotWithShape="1">
+          <a:gsLst>
+            <a:gs pos="0">
+              <a:schemeClr val="phClr">
+                <a:lumMod val="110000"/>
+                <a:satMod val="105000"/>
+                <a:tint val="67000"/>
+              </a:schemeClr>
+            </a:gs>
+            <a:gs pos="50000">
+              <a:schemeClr val="phClr">
+                <a:lumMod val="105000"/>
+                <a:satMod val="103000"/>
+                <a:tint val="73000"/>
+              </a:schemeClr>
+            </a:gs>
+            <a:gs pos="100000">
+              <a:schemeClr val="phClr">
+                <a:lumMod val="105000"/>
+                <a:satMod val="109000"/>
+                <a:tint val="81000"/>
+              </a:schemeClr>
+            </a:gs>
+          </a:gsLst>
+          <a:lin ang="5400000" scaled="0"/>
+        </a:gradFill>
+        <a:gradFill rotWithShape="1">
+          <a:gsLst>
+            <a:gs pos="0">
+              <a:schemeClr val="phClr">
+                <a:satMod val="103000"/>
+                <a:lumMod val="102000"/>
+                <a:tint val="94000"/>
+              </a:schemeClr>
+            </a:gs>
+            <a:gs pos="50000">
+              <a:schemeClr val="phClr">
+                <a:satMod val="110000"/>
+                <a:lumMod val="100000"/>
+                <a:shade val="100000"/>
+              </a:schemeClr>
+            </a:gs>
+            <a:gs pos="100000">
+              <a:schemeClr val="phClr">
+                <a:lumMod val="99000"/>
+                <a:satMod val="120000"/>
+                <a:shade val="78000"/>
+              </a:schemeClr>
+            </a:gs>
+          </a:gsLst>
+          <a:lin ang="5400000" scaled="0"/>
+        </a:gradFill>
+      </a:fillStyleLst>
+      <a:lnStyleLst>
+        <a:ln w="12700" cap="flat" cmpd="sng" algn="ctr">
+          <a:solidFill>
+            <a:schemeClr val="phClr"/>
+          </a:solidFill>
+          <a:prstDash val="solid"/>
+          <a:miter lim="800000"/>
+        </a:ln>
+        <a:ln w="19050" cap="flat" cmpd="sng" algn="ctr">
+          <a:solidFill>
+            <a:schemeClr val="phClr"/>
+          </a:solidFill>
+          <a:prstDash val="solid"/>
+          <a:miter lim="800000"/>
+        </a:ln>
+        <a:ln w="25400" cap="flat" cmpd="sng" algn="ctr">
+          <a:solidFill>
+            <a:schemeClr val="phClr"/>
+          </a:solidFill>
+          <a:prstDash val="solid"/>
+          <a:miter lim="800000"/>
+        </a:ln>
+      </a:lnStyleLst>
+      <a:effectStyleLst>
+        <a:effectStyle>
+          <a:effectLst/>
+        </a:effectStyle>
+        <a:effectStyle>
+          <a:effectLst/>
+        </a:effectStyle>
+        <a:effectStyle>
+          <a:effectLst>
+            <a:outerShdw blurRad="57150" dist="19050" dir="5400000" algn="ctr" rotWithShape="0">
+              <a:srgbClr val="000000">
+                <a:alpha val="63000"/>
+              </a:srgbClr>
+            </a:outerShdw>
+          </a:effectLst>
+        </a:effectStyle>
+      </a:effectStyleLst>
+      <a:bgFillStyleLst>
+        <a:solidFill>
+          <a:schemeClr val="phClr"/>
+        </a:solidFill>
+        <a:solidFill>
+          <a:schemeClr val="phClr">
+            <a:tint val="95000"/>
+            <a:satMod val="170000"/>
+          </a:schemeClr>
+        </a:solidFill>
+        <a:gradFill rotWithShape="1">
+          <a:gsLst>
+            <a:gs pos="0">
+              <a:schemeClr val="phClr">
+                <a:tint val="93000"/>
+                <a:satMod val="150000"/>
+                <a:shade val="98000"/>
+                <a:lumMod val="102000"/>
+              </a:schemeClr>
+            </a:gs>
+            <a:gs pos="50000">
+              <a:schemeClr val="phClr">
+                <a:tint val="98000"/>
+                <a:satMod val="130000"/>
+                <a:shade val="90000"/>
+                <a:lumMod val="103000"/>
+              </a:schemeClr>
+            </a:gs>
+            <a:gs pos="100000">
+              <a:schemeClr val="phClr">
+                <a:shade val="63000"/>
+                <a:satMod val="120000"/>
+              </a:schemeClr>
+            </a:gs>
+          </a:gsLst>
+          <a:lin ang="5400000" scaled="0"/>
+        </a:gradFill>
+      </a:bgFillStyleLst>
+    </a:fmtScheme>
+  </a:themeElements>
+  <a:objectDefaults>
+    <a:lnDef>
+      <a:spPr/>
+      <a:bodyPr/>
+      <a:lstStyle/>
+      <a:style>
+        <a:lnRef idx="2">
+          <a:schemeClr val="accent1"/>
+        </a:lnRef>
+        <a:fillRef idx="0">
+          <a:schemeClr val="accent1"/>
+        </a:fillRef>
+        <a:effectRef idx="1">
+          <a:schemeClr val="accent1"/>
+        </a:effectRef>
+        <a:fontRef idx="minor">
+          <a:schemeClr val="tx1"/>
+        </a:fontRef>
+      </a:style>
+    </a:lnDef>
+  </a:objectDefaults>
+  <a:extraClrSchemeLst/>
+  <a:extLst>
+    <a:ext uri="{05A4C25C-085E-4340-85A3-A5531E510DB2}">
+      <thm15:themeFamily xmlns:thm15="http://schemas.microsoft.com/office/thememl/2012/main" name="Office Theme" id="{2E142A2C-CD16-42D6-873A-C26D2A0506FA}" vid="{1BDDFF52-6CD6-40A5-AB3C-68EB2F1E4D0A}"/>
+    </a:ext>
+  </a:extLst>
+</a:theme>
 </file>
</xml_diff>